<commit_message>
Cleaning-up & updateing lecture 4
</commit_message>
<xml_diff>
--- a/Figuras/Figuras_prep.pptx
+++ b/Figuras/Figuras_prep.pptx
@@ -17,12 +17,13 @@
     <p:sldId id="267" r:id="rId11"/>
     <p:sldId id="269" r:id="rId12"/>
     <p:sldId id="270" r:id="rId13"/>
-    <p:sldId id="271" r:id="rId14"/>
-    <p:sldId id="278" r:id="rId15"/>
-    <p:sldId id="279" r:id="rId16"/>
-    <p:sldId id="274" r:id="rId17"/>
-    <p:sldId id="276" r:id="rId18"/>
-    <p:sldId id="277" r:id="rId19"/>
+    <p:sldId id="280" r:id="rId14"/>
+    <p:sldId id="271" r:id="rId15"/>
+    <p:sldId id="278" r:id="rId16"/>
+    <p:sldId id="279" r:id="rId17"/>
+    <p:sldId id="274" r:id="rId18"/>
+    <p:sldId id="276" r:id="rId19"/>
+    <p:sldId id="277" r:id="rId20"/>
   </p:sldIdLst>
   <p:sldSz cx="12192000" cy="6858000"/>
   <p:notesSz cx="6858000" cy="9144000"/>
@@ -132,7 +133,7 @@
 <file path=ppt/revisionInfo.xml><?xml version="1.0" encoding="utf-8"?>
 <p1510:revInfo xmlns:a="http://schemas.openxmlformats.org/drawingml/2006/main" xmlns:r="http://schemas.openxmlformats.org/officeDocument/2006/relationships" xmlns:p1510="http://schemas.microsoft.com/office/powerpoint/2015/10/main">
   <p1510:revLst>
-    <p1510:client id="{E8589E22-55F0-D245-B7BA-3FB71ADCAD28}" v="413" dt="2026-08-13T21:00:10.019"/>
+    <p1510:client id="{E8589E22-55F0-D245-B7BA-3FB71ADCAD28}" v="545" dt="2026-08-14T15:18:40.435"/>
   </p1510:revLst>
 </p1510:revInfo>
 </file>
@@ -142,7 +143,7 @@
   <pc:docChgLst>
     <pc:chgData name="Marie-Christine Rufener" userId="2d6664cfb518d05c" providerId="LiveId" clId="{946B3BF8-DE9F-57F9-A118-BDE1986E26EE}"/>
     <pc:docChg chg="undo redo custSel addSld delSld modSld sldOrd">
-      <pc:chgData name="Marie-Christine Rufener" userId="2d6664cfb518d05c" providerId="LiveId" clId="{946B3BF8-DE9F-57F9-A118-BDE1986E26EE}" dt="2026-08-13T22:33:37.166" v="8318" actId="478"/>
+      <pc:chgData name="Marie-Christine Rufener" userId="2d6664cfb518d05c" providerId="LiveId" clId="{946B3BF8-DE9F-57F9-A118-BDE1986E26EE}" dt="2026-08-14T15:19:08.899" v="8943" actId="164"/>
       <pc:docMkLst>
         <pc:docMk/>
       </pc:docMkLst>
@@ -4255,6 +4256,341 @@
             <ac:picMk id="3" creationId="{C4D1CF19-6EAB-CFF2-B4BA-B8C20A4FA2B2}"/>
           </ac:picMkLst>
         </pc:picChg>
+      </pc:sldChg>
+      <pc:sldChg chg="addSp delSp modSp new mod ord">
+        <pc:chgData name="Marie-Christine Rufener" userId="2d6664cfb518d05c" providerId="LiveId" clId="{946B3BF8-DE9F-57F9-A118-BDE1986E26EE}" dt="2026-08-14T15:19:08.899" v="8943" actId="164"/>
+        <pc:sldMkLst>
+          <pc:docMk/>
+          <pc:sldMk cId="1995668596" sldId="280"/>
+        </pc:sldMkLst>
+        <pc:spChg chg="add mod">
+          <ac:chgData name="Marie-Christine Rufener" userId="2d6664cfb518d05c" providerId="LiveId" clId="{946B3BF8-DE9F-57F9-A118-BDE1986E26EE}" dt="2026-08-14T15:09:55.560" v="8731" actId="207"/>
+          <ac:spMkLst>
+            <pc:docMk/>
+            <pc:sldMk cId="1995668596" sldId="280"/>
+            <ac:spMk id="32" creationId="{0A2BC88F-3C6D-065B-B01C-D2416EF5E913}"/>
+          </ac:spMkLst>
+        </pc:spChg>
+        <pc:spChg chg="add del mod">
+          <ac:chgData name="Marie-Christine Rufener" userId="2d6664cfb518d05c" providerId="LiveId" clId="{946B3BF8-DE9F-57F9-A118-BDE1986E26EE}" dt="2026-08-14T14:56:28.949" v="8477"/>
+          <ac:spMkLst>
+            <pc:docMk/>
+            <pc:sldMk cId="1995668596" sldId="280"/>
+            <ac:spMk id="33" creationId="{312954F0-B4C6-DA1D-2092-209805A8A258}"/>
+          </ac:spMkLst>
+        </pc:spChg>
+        <pc:spChg chg="add del mod">
+          <ac:chgData name="Marie-Christine Rufener" userId="2d6664cfb518d05c" providerId="LiveId" clId="{946B3BF8-DE9F-57F9-A118-BDE1986E26EE}" dt="2026-08-14T14:56:29.484" v="8479"/>
+          <ac:spMkLst>
+            <pc:docMk/>
+            <pc:sldMk cId="1995668596" sldId="280"/>
+            <ac:spMk id="34" creationId="{0412D6FD-CE74-E74B-80C5-1F25EC6A917C}"/>
+          </ac:spMkLst>
+        </pc:spChg>
+        <pc:spChg chg="add mod">
+          <ac:chgData name="Marie-Christine Rufener" userId="2d6664cfb518d05c" providerId="LiveId" clId="{946B3BF8-DE9F-57F9-A118-BDE1986E26EE}" dt="2026-08-14T15:16:18.499" v="8929" actId="1076"/>
+          <ac:spMkLst>
+            <pc:docMk/>
+            <pc:sldMk cId="1995668596" sldId="280"/>
+            <ac:spMk id="35" creationId="{5FA129F4-AB94-94E2-20E3-7D317EC82773}"/>
+          </ac:spMkLst>
+        </pc:spChg>
+        <pc:spChg chg="add mod">
+          <ac:chgData name="Marie-Christine Rufener" userId="2d6664cfb518d05c" providerId="LiveId" clId="{946B3BF8-DE9F-57F9-A118-BDE1986E26EE}" dt="2026-08-14T15:12:52.274" v="8898" actId="1035"/>
+          <ac:spMkLst>
+            <pc:docMk/>
+            <pc:sldMk cId="1995668596" sldId="280"/>
+            <ac:spMk id="37" creationId="{87E44ED8-AF6B-526B-F1CF-CF37C6B581F1}"/>
+          </ac:spMkLst>
+        </pc:spChg>
+        <pc:spChg chg="add mod">
+          <ac:chgData name="Marie-Christine Rufener" userId="2d6664cfb518d05c" providerId="LiveId" clId="{946B3BF8-DE9F-57F9-A118-BDE1986E26EE}" dt="2026-08-14T15:12:52.274" v="8898" actId="1035"/>
+          <ac:spMkLst>
+            <pc:docMk/>
+            <pc:sldMk cId="1995668596" sldId="280"/>
+            <ac:spMk id="38" creationId="{A92EFDDF-E56A-B371-CBF7-2620662D30D8}"/>
+          </ac:spMkLst>
+        </pc:spChg>
+        <pc:spChg chg="add mod">
+          <ac:chgData name="Marie-Christine Rufener" userId="2d6664cfb518d05c" providerId="LiveId" clId="{946B3BF8-DE9F-57F9-A118-BDE1986E26EE}" dt="2026-08-14T15:12:52.274" v="8898" actId="1035"/>
+          <ac:spMkLst>
+            <pc:docMk/>
+            <pc:sldMk cId="1995668596" sldId="280"/>
+            <ac:spMk id="39" creationId="{21FD1E90-CE2C-A1C6-6E5E-E509841F6E75}"/>
+          </ac:spMkLst>
+        </pc:spChg>
+        <pc:spChg chg="add mod">
+          <ac:chgData name="Marie-Christine Rufener" userId="2d6664cfb518d05c" providerId="LiveId" clId="{946B3BF8-DE9F-57F9-A118-BDE1986E26EE}" dt="2026-08-14T15:12:52.274" v="8898" actId="1035"/>
+          <ac:spMkLst>
+            <pc:docMk/>
+            <pc:sldMk cId="1995668596" sldId="280"/>
+            <ac:spMk id="40" creationId="{7487E948-ECD6-6666-D485-3BA0A2967403}"/>
+          </ac:spMkLst>
+        </pc:spChg>
+        <pc:spChg chg="add mod">
+          <ac:chgData name="Marie-Christine Rufener" userId="2d6664cfb518d05c" providerId="LiveId" clId="{946B3BF8-DE9F-57F9-A118-BDE1986E26EE}" dt="2026-08-14T15:12:52.274" v="8898" actId="1035"/>
+          <ac:spMkLst>
+            <pc:docMk/>
+            <pc:sldMk cId="1995668596" sldId="280"/>
+            <ac:spMk id="41" creationId="{93DFD1D4-1004-FECC-F7F5-719B3280A53F}"/>
+          </ac:spMkLst>
+        </pc:spChg>
+        <pc:spChg chg="add mod">
+          <ac:chgData name="Marie-Christine Rufener" userId="2d6664cfb518d05c" providerId="LiveId" clId="{946B3BF8-DE9F-57F9-A118-BDE1986E26EE}" dt="2026-08-14T15:10:05.163" v="8736" actId="1036"/>
+          <ac:spMkLst>
+            <pc:docMk/>
+            <pc:sldMk cId="1995668596" sldId="280"/>
+            <ac:spMk id="60" creationId="{99F515A5-D328-C211-CA4A-CD84C5785392}"/>
+          </ac:spMkLst>
+        </pc:spChg>
+        <pc:spChg chg="add mod">
+          <ac:chgData name="Marie-Christine Rufener" userId="2d6664cfb518d05c" providerId="LiveId" clId="{946B3BF8-DE9F-57F9-A118-BDE1986E26EE}" dt="2026-08-14T15:13:38.085" v="8907" actId="207"/>
+          <ac:spMkLst>
+            <pc:docMk/>
+            <pc:sldMk cId="1995668596" sldId="280"/>
+            <ac:spMk id="61" creationId="{0C73520D-7D4F-DAAB-6555-771081ED2139}"/>
+          </ac:spMkLst>
+        </pc:spChg>
+        <pc:spChg chg="add del mod">
+          <ac:chgData name="Marie-Christine Rufener" userId="2d6664cfb518d05c" providerId="LiveId" clId="{946B3BF8-DE9F-57F9-A118-BDE1986E26EE}" dt="2026-08-14T15:12:56.367" v="8899" actId="478"/>
+          <ac:spMkLst>
+            <pc:docMk/>
+            <pc:sldMk cId="1995668596" sldId="280"/>
+            <ac:spMk id="62" creationId="{697E6FD5-ED94-F458-836F-3C8DA883E059}"/>
+          </ac:spMkLst>
+        </pc:spChg>
+        <pc:spChg chg="add del mod">
+          <ac:chgData name="Marie-Christine Rufener" userId="2d6664cfb518d05c" providerId="LiveId" clId="{946B3BF8-DE9F-57F9-A118-BDE1986E26EE}" dt="2026-08-14T15:12:56.367" v="8899" actId="478"/>
+          <ac:spMkLst>
+            <pc:docMk/>
+            <pc:sldMk cId="1995668596" sldId="280"/>
+            <ac:spMk id="63" creationId="{D1882152-2B79-EF7D-2553-9C092DBF04B8}"/>
+          </ac:spMkLst>
+        </pc:spChg>
+        <pc:spChg chg="add del mod">
+          <ac:chgData name="Marie-Christine Rufener" userId="2d6664cfb518d05c" providerId="LiveId" clId="{946B3BF8-DE9F-57F9-A118-BDE1986E26EE}" dt="2026-08-14T15:12:56.367" v="8899" actId="478"/>
+          <ac:spMkLst>
+            <pc:docMk/>
+            <pc:sldMk cId="1995668596" sldId="280"/>
+            <ac:spMk id="64" creationId="{D052F601-B5FB-30AB-7CFE-F10864F61C9F}"/>
+          </ac:spMkLst>
+        </pc:spChg>
+        <pc:spChg chg="add del mod">
+          <ac:chgData name="Marie-Christine Rufener" userId="2d6664cfb518d05c" providerId="LiveId" clId="{946B3BF8-DE9F-57F9-A118-BDE1986E26EE}" dt="2026-08-14T15:12:56.367" v="8899" actId="478"/>
+          <ac:spMkLst>
+            <pc:docMk/>
+            <pc:sldMk cId="1995668596" sldId="280"/>
+            <ac:spMk id="65" creationId="{7D5C3A7C-FEA5-8A19-400E-190CE1AAA0B3}"/>
+          </ac:spMkLst>
+        </pc:spChg>
+        <pc:spChg chg="add del mod">
+          <ac:chgData name="Marie-Christine Rufener" userId="2d6664cfb518d05c" providerId="LiveId" clId="{946B3BF8-DE9F-57F9-A118-BDE1986E26EE}" dt="2026-08-14T15:12:52.274" v="8898" actId="1035"/>
+          <ac:spMkLst>
+            <pc:docMk/>
+            <pc:sldMk cId="1995668596" sldId="280"/>
+            <ac:spMk id="66" creationId="{04EC279C-6677-03B4-D1E4-717126AE8E01}"/>
+          </ac:spMkLst>
+        </pc:spChg>
+        <pc:spChg chg="add mod">
+          <ac:chgData name="Marie-Christine Rufener" userId="2d6664cfb518d05c" providerId="LiveId" clId="{946B3BF8-DE9F-57F9-A118-BDE1986E26EE}" dt="2026-08-14T15:13:14.495" v="8903" actId="1038"/>
+          <ac:spMkLst>
+            <pc:docMk/>
+            <pc:sldMk cId="1995668596" sldId="280"/>
+            <ac:spMk id="67" creationId="{F683B5FE-1DD6-90A8-B325-6F09DDC0B3E1}"/>
+          </ac:spMkLst>
+        </pc:spChg>
+        <pc:spChg chg="add mod">
+          <ac:chgData name="Marie-Christine Rufener" userId="2d6664cfb518d05c" providerId="LiveId" clId="{946B3BF8-DE9F-57F9-A118-BDE1986E26EE}" dt="2026-08-14T15:16:04.837" v="8926" actId="122"/>
+          <ac:spMkLst>
+            <pc:docMk/>
+            <pc:sldMk cId="1995668596" sldId="280"/>
+            <ac:spMk id="68" creationId="{59B3F19F-8B25-2052-6750-2B94348D6985}"/>
+          </ac:spMkLst>
+        </pc:spChg>
+        <pc:spChg chg="add mod">
+          <ac:chgData name="Marie-Christine Rufener" userId="2d6664cfb518d05c" providerId="LiveId" clId="{946B3BF8-DE9F-57F9-A118-BDE1986E26EE}" dt="2026-08-14T15:19:02.720" v="8942" actId="208"/>
+          <ac:spMkLst>
+            <pc:docMk/>
+            <pc:sldMk cId="1995668596" sldId="280"/>
+            <ac:spMk id="70" creationId="{C31800BA-3AF1-723E-CEDF-EC8624F1C4DB}"/>
+          </ac:spMkLst>
+        </pc:spChg>
+        <pc:grpChg chg="add">
+          <ac:chgData name="Marie-Christine Rufener" userId="2d6664cfb518d05c" providerId="LiveId" clId="{946B3BF8-DE9F-57F9-A118-BDE1986E26EE}" dt="2026-08-14T15:16:25.887" v="8930" actId="164"/>
+          <ac:grpSpMkLst>
+            <pc:docMk/>
+            <pc:sldMk cId="1995668596" sldId="280"/>
+            <ac:grpSpMk id="69" creationId="{9AA77DDB-C9CF-5904-5D44-F6275B53432A}"/>
+          </ac:grpSpMkLst>
+        </pc:grpChg>
+        <pc:grpChg chg="add">
+          <ac:chgData name="Marie-Christine Rufener" userId="2d6664cfb518d05c" providerId="LiveId" clId="{946B3BF8-DE9F-57F9-A118-BDE1986E26EE}" dt="2026-08-14T15:19:08.899" v="8943" actId="164"/>
+          <ac:grpSpMkLst>
+            <pc:docMk/>
+            <pc:sldMk cId="1995668596" sldId="280"/>
+            <ac:grpSpMk id="71" creationId="{6432A2B9-4612-825E-20AF-D20CD8E7C201}"/>
+          </ac:grpSpMkLst>
+        </pc:grpChg>
+        <pc:picChg chg="add del mod">
+          <ac:chgData name="Marie-Christine Rufener" userId="2d6664cfb518d05c" providerId="LiveId" clId="{946B3BF8-DE9F-57F9-A118-BDE1986E26EE}" dt="2026-08-14T14:45:26.930" v="8325" actId="478"/>
+          <ac:picMkLst>
+            <pc:docMk/>
+            <pc:sldMk cId="1995668596" sldId="280"/>
+            <ac:picMk id="3" creationId="{778CADFD-413F-FE58-6FEE-FEDDB4DB0F82}"/>
+          </ac:picMkLst>
+        </pc:picChg>
+        <pc:picChg chg="add del mod">
+          <ac:chgData name="Marie-Christine Rufener" userId="2d6664cfb518d05c" providerId="LiveId" clId="{946B3BF8-DE9F-57F9-A118-BDE1986E26EE}" dt="2026-08-14T14:49:05.871" v="8332" actId="478"/>
+          <ac:picMkLst>
+            <pc:docMk/>
+            <pc:sldMk cId="1995668596" sldId="280"/>
+            <ac:picMk id="5" creationId="{B2080E59-8348-5D04-003E-380C0417E09A}"/>
+          </ac:picMkLst>
+        </pc:picChg>
+        <pc:picChg chg="add del mod">
+          <ac:chgData name="Marie-Christine Rufener" userId="2d6664cfb518d05c" providerId="LiveId" clId="{946B3BF8-DE9F-57F9-A118-BDE1986E26EE}" dt="2026-08-14T14:49:19.956" v="8340" actId="478"/>
+          <ac:picMkLst>
+            <pc:docMk/>
+            <pc:sldMk cId="1995668596" sldId="280"/>
+            <ac:picMk id="7" creationId="{4A7DBCC3-7723-4604-2E33-6F410127158A}"/>
+          </ac:picMkLst>
+        </pc:picChg>
+        <pc:picChg chg="add mod modCrop">
+          <ac:chgData name="Marie-Christine Rufener" userId="2d6664cfb518d05c" providerId="LiveId" clId="{946B3BF8-DE9F-57F9-A118-BDE1986E26EE}" dt="2026-08-14T14:51:24.790" v="8360" actId="732"/>
+          <ac:picMkLst>
+            <pc:docMk/>
+            <pc:sldMk cId="1995668596" sldId="280"/>
+            <ac:picMk id="9" creationId="{5321E672-6B7E-70E7-6FEC-C1A9DB76E49F}"/>
+          </ac:picMkLst>
+        </pc:picChg>
+        <pc:picChg chg="add mod modCrop">
+          <ac:chgData name="Marie-Christine Rufener" userId="2d6664cfb518d05c" providerId="LiveId" clId="{946B3BF8-DE9F-57F9-A118-BDE1986E26EE}" dt="2026-08-14T15:07:04.263" v="8611" actId="1076"/>
+          <ac:picMkLst>
+            <pc:docMk/>
+            <pc:sldMk cId="1995668596" sldId="280"/>
+            <ac:picMk id="14" creationId="{5ED8E0FE-F016-0E2C-D477-13AD495991D0}"/>
+          </ac:picMkLst>
+        </pc:picChg>
+        <pc:cxnChg chg="add mod">
+          <ac:chgData name="Marie-Christine Rufener" userId="2d6664cfb518d05c" providerId="LiveId" clId="{946B3BF8-DE9F-57F9-A118-BDE1986E26EE}" dt="2026-08-14T14:52:30.993" v="8421" actId="1036"/>
+          <ac:cxnSpMkLst>
+            <pc:docMk/>
+            <pc:sldMk cId="1995668596" sldId="280"/>
+            <ac:cxnSpMk id="11" creationId="{67045C29-92EC-A4F5-905F-DDB380B4AC76}"/>
+          </ac:cxnSpMkLst>
+        </pc:cxnChg>
+        <pc:cxnChg chg="add mod">
+          <ac:chgData name="Marie-Christine Rufener" userId="2d6664cfb518d05c" providerId="LiveId" clId="{946B3BF8-DE9F-57F9-A118-BDE1986E26EE}" dt="2026-08-14T14:51:59.917" v="8374" actId="1037"/>
+          <ac:cxnSpMkLst>
+            <pc:docMk/>
+            <pc:sldMk cId="1995668596" sldId="280"/>
+            <ac:cxnSpMk id="15" creationId="{F0E1B570-4BD7-98D4-8FBE-5262EC55B25F}"/>
+          </ac:cxnSpMkLst>
+        </pc:cxnChg>
+        <pc:cxnChg chg="add mod">
+          <ac:chgData name="Marie-Christine Rufener" userId="2d6664cfb518d05c" providerId="LiveId" clId="{946B3BF8-DE9F-57F9-A118-BDE1986E26EE}" dt="2026-08-14T14:52:12.050" v="8418" actId="1035"/>
+          <ac:cxnSpMkLst>
+            <pc:docMk/>
+            <pc:sldMk cId="1995668596" sldId="280"/>
+            <ac:cxnSpMk id="19" creationId="{172426A7-DC0B-4CF9-1689-ABDBFAE7BBE5}"/>
+          </ac:cxnSpMkLst>
+        </pc:cxnChg>
+        <pc:cxnChg chg="add mod">
+          <ac:chgData name="Marie-Christine Rufener" userId="2d6664cfb518d05c" providerId="LiveId" clId="{946B3BF8-DE9F-57F9-A118-BDE1986E26EE}" dt="2026-08-14T15:08:17.628" v="8686" actId="14100"/>
+          <ac:cxnSpMkLst>
+            <pc:docMk/>
+            <pc:sldMk cId="1995668596" sldId="280"/>
+            <ac:cxnSpMk id="22" creationId="{E82698A2-4E00-1AAE-DF08-2095CA6A48C8}"/>
+          </ac:cxnSpMkLst>
+        </pc:cxnChg>
+        <pc:cxnChg chg="add mod">
+          <ac:chgData name="Marie-Christine Rufener" userId="2d6664cfb518d05c" providerId="LiveId" clId="{946B3BF8-DE9F-57F9-A118-BDE1986E26EE}" dt="2026-08-14T15:08:14.534" v="8685" actId="14100"/>
+          <ac:cxnSpMkLst>
+            <pc:docMk/>
+            <pc:sldMk cId="1995668596" sldId="280"/>
+            <ac:cxnSpMk id="24" creationId="{923AB6CC-F065-F0B4-4B36-BBFFB2BC594C}"/>
+          </ac:cxnSpMkLst>
+        </pc:cxnChg>
+        <pc:cxnChg chg="add mod">
+          <ac:chgData name="Marie-Christine Rufener" userId="2d6664cfb518d05c" providerId="LiveId" clId="{946B3BF8-DE9F-57F9-A118-BDE1986E26EE}" dt="2026-08-14T15:08:09.342" v="8684" actId="14100"/>
+          <ac:cxnSpMkLst>
+            <pc:docMk/>
+            <pc:sldMk cId="1995668596" sldId="280"/>
+            <ac:cxnSpMk id="26" creationId="{0F0085C9-AB09-E7FF-124B-A9921D49F7FB}"/>
+          </ac:cxnSpMkLst>
+        </pc:cxnChg>
+        <pc:cxnChg chg="add mod">
+          <ac:chgData name="Marie-Christine Rufener" userId="2d6664cfb518d05c" providerId="LiveId" clId="{946B3BF8-DE9F-57F9-A118-BDE1986E26EE}" dt="2026-08-14T15:08:06.720" v="8683" actId="14100"/>
+          <ac:cxnSpMkLst>
+            <pc:docMk/>
+            <pc:sldMk cId="1995668596" sldId="280"/>
+            <ac:cxnSpMk id="28" creationId="{1B1CC2F2-DE08-F6AA-84BB-A48D210BD97D}"/>
+          </ac:cxnSpMkLst>
+        </pc:cxnChg>
+        <pc:cxnChg chg="add mod">
+          <ac:chgData name="Marie-Christine Rufener" userId="2d6664cfb518d05c" providerId="LiveId" clId="{946B3BF8-DE9F-57F9-A118-BDE1986E26EE}" dt="2026-08-14T15:08:01.837" v="8682" actId="14100"/>
+          <ac:cxnSpMkLst>
+            <pc:docMk/>
+            <pc:sldMk cId="1995668596" sldId="280"/>
+            <ac:cxnSpMk id="30" creationId="{CB39B40C-4576-1F00-C3DF-2B126298368E}"/>
+          </ac:cxnSpMkLst>
+        </pc:cxnChg>
+        <pc:cxnChg chg="add del mod">
+          <ac:chgData name="Marie-Christine Rufener" userId="2d6664cfb518d05c" providerId="LiveId" clId="{946B3BF8-DE9F-57F9-A118-BDE1986E26EE}" dt="2026-08-14T14:59:21.131" v="8513" actId="478"/>
+          <ac:cxnSpMkLst>
+            <pc:docMk/>
+            <pc:sldMk cId="1995668596" sldId="280"/>
+            <ac:cxnSpMk id="36" creationId="{14DE7B2C-C92F-88F7-632D-FFD14F1CF6BF}"/>
+          </ac:cxnSpMkLst>
+        </pc:cxnChg>
+        <pc:cxnChg chg="add mod">
+          <ac:chgData name="Marie-Christine Rufener" userId="2d6664cfb518d05c" providerId="LiveId" clId="{946B3BF8-DE9F-57F9-A118-BDE1986E26EE}" dt="2026-08-14T15:07:48.293" v="8678" actId="1035"/>
+          <ac:cxnSpMkLst>
+            <pc:docMk/>
+            <pc:sldMk cId="1995668596" sldId="280"/>
+            <ac:cxnSpMk id="43" creationId="{1D99A336-64C8-53BD-CCA0-C74BE5F39BBE}"/>
+          </ac:cxnSpMkLst>
+        </pc:cxnChg>
+        <pc:cxnChg chg="add mod">
+          <ac:chgData name="Marie-Christine Rufener" userId="2d6664cfb518d05c" providerId="LiveId" clId="{946B3BF8-DE9F-57F9-A118-BDE1986E26EE}" dt="2026-08-14T15:07:51.532" v="8679" actId="1035"/>
+          <ac:cxnSpMkLst>
+            <pc:docMk/>
+            <pc:sldMk cId="1995668596" sldId="280"/>
+            <ac:cxnSpMk id="45" creationId="{8C49943E-88F0-C0CC-56FC-C7A1F3A9A291}"/>
+          </ac:cxnSpMkLst>
+        </pc:cxnChg>
+        <pc:cxnChg chg="add mod">
+          <ac:chgData name="Marie-Christine Rufener" userId="2d6664cfb518d05c" providerId="LiveId" clId="{946B3BF8-DE9F-57F9-A118-BDE1986E26EE}" dt="2026-08-14T15:07:46.422" v="8677" actId="1035"/>
+          <ac:cxnSpMkLst>
+            <pc:docMk/>
+            <pc:sldMk cId="1995668596" sldId="280"/>
+            <ac:cxnSpMk id="47" creationId="{F5D99511-7E2C-5FFA-B45B-E957585C5458}"/>
+          </ac:cxnSpMkLst>
+        </pc:cxnChg>
+        <pc:cxnChg chg="add mod">
+          <ac:chgData name="Marie-Christine Rufener" userId="2d6664cfb518d05c" providerId="LiveId" clId="{946B3BF8-DE9F-57F9-A118-BDE1986E26EE}" dt="2026-08-14T15:07:54.275" v="8680" actId="1035"/>
+          <ac:cxnSpMkLst>
+            <pc:docMk/>
+            <pc:sldMk cId="1995668596" sldId="280"/>
+            <ac:cxnSpMk id="49" creationId="{031071CB-8A83-7B70-6AC2-44026C1EC2A6}"/>
+          </ac:cxnSpMkLst>
+        </pc:cxnChg>
+        <pc:cxnChg chg="add mod">
+          <ac:chgData name="Marie-Christine Rufener" userId="2d6664cfb518d05c" providerId="LiveId" clId="{946B3BF8-DE9F-57F9-A118-BDE1986E26EE}" dt="2026-08-14T15:07:58.402" v="8681" actId="692"/>
+          <ac:cxnSpMkLst>
+            <pc:docMk/>
+            <pc:sldMk cId="1995668596" sldId="280"/>
+            <ac:cxnSpMk id="51" creationId="{5FC5DE2A-1AA4-5AE1-6B86-F62422708AD8}"/>
+          </ac:cxnSpMkLst>
+        </pc:cxnChg>
+        <pc:cxnChg chg="add mod">
+          <ac:chgData name="Marie-Christine Rufener" userId="2d6664cfb518d05c" providerId="LiveId" clId="{946B3BF8-DE9F-57F9-A118-BDE1986E26EE}" dt="2026-08-14T15:09:02.426" v="8690" actId="692"/>
+          <ac:cxnSpMkLst>
+            <pc:docMk/>
+            <pc:sldMk cId="1995668596" sldId="280"/>
+            <ac:cxnSpMk id="58" creationId="{1D47C2BE-97C7-5AAD-C7D9-0CAF8BFB3FB2}"/>
+          </ac:cxnSpMkLst>
+        </pc:cxnChg>
       </pc:sldChg>
     </pc:docChg>
   </pc:docChgLst>
@@ -11929,6 +12265,2060 @@
       </p:grpSpPr>
       <p:grpSp>
         <p:nvGrpSpPr>
+          <p:cNvPr id="71" name="Group 70">
+            <a:extLst>
+              <a:ext uri="{FF2B5EF4-FFF2-40B4-BE49-F238E27FC236}">
+                <a16:creationId xmlns:a16="http://schemas.microsoft.com/office/drawing/2014/main" id="{6432A2B9-4612-825E-20AF-D20CD8E7C201}"/>
+              </a:ext>
+            </a:extLst>
+          </p:cNvPr>
+          <p:cNvGrpSpPr/>
+          <p:nvPr/>
+        </p:nvGrpSpPr>
+        <p:grpSpPr>
+          <a:xfrm>
+            <a:off x="408212" y="-146957"/>
+            <a:ext cx="11150051" cy="7602891"/>
+            <a:chOff x="408212" y="-146957"/>
+            <a:chExt cx="11150051" cy="7602891"/>
+          </a:xfrm>
+        </p:grpSpPr>
+        <p:sp>
+          <p:nvSpPr>
+            <p:cNvPr id="70" name="Rectangle 69">
+              <a:extLst>
+                <a:ext uri="{FF2B5EF4-FFF2-40B4-BE49-F238E27FC236}">
+                  <a16:creationId xmlns:a16="http://schemas.microsoft.com/office/drawing/2014/main" id="{C31800BA-3AF1-723E-CEDF-EC8624F1C4DB}"/>
+                </a:ext>
+              </a:extLst>
+            </p:cNvPr>
+            <p:cNvSpPr/>
+            <p:nvPr/>
+          </p:nvSpPr>
+          <p:spPr>
+            <a:xfrm>
+              <a:off x="408212" y="-146957"/>
+              <a:ext cx="11150051" cy="7233560"/>
+            </a:xfrm>
+            <a:prstGeom prst="rect">
+              <a:avLst/>
+            </a:prstGeom>
+            <a:solidFill>
+              <a:schemeClr val="bg1"/>
+            </a:solidFill>
+            <a:ln>
+              <a:solidFill>
+                <a:schemeClr val="bg1"/>
+              </a:solidFill>
+            </a:ln>
+          </p:spPr>
+          <p:style>
+            <a:lnRef idx="2">
+              <a:schemeClr val="accent1">
+                <a:shade val="15000"/>
+              </a:schemeClr>
+            </a:lnRef>
+            <a:fillRef idx="1">
+              <a:schemeClr val="accent1"/>
+            </a:fillRef>
+            <a:effectRef idx="0">
+              <a:schemeClr val="accent1"/>
+            </a:effectRef>
+            <a:fontRef idx="minor">
+              <a:schemeClr val="lt1"/>
+            </a:fontRef>
+          </p:style>
+          <p:txBody>
+            <a:bodyPr rtlCol="0" anchor="ctr"/>
+            <a:lstStyle/>
+            <a:p>
+              <a:pPr algn="ctr"/>
+              <a:endParaRPr lang="en-US"/>
+            </a:p>
+          </p:txBody>
+        </p:sp>
+        <p:grpSp>
+          <p:nvGrpSpPr>
+            <p:cNvPr id="69" name="Group 68">
+              <a:extLst>
+                <a:ext uri="{FF2B5EF4-FFF2-40B4-BE49-F238E27FC236}">
+                  <a16:creationId xmlns:a16="http://schemas.microsoft.com/office/drawing/2014/main" id="{9AA77DDB-C9CF-5904-5D44-F6275B53432A}"/>
+                </a:ext>
+              </a:extLst>
+            </p:cNvPr>
+            <p:cNvGrpSpPr/>
+            <p:nvPr/>
+          </p:nvGrpSpPr>
+          <p:grpSpPr>
+            <a:xfrm>
+              <a:off x="702365" y="200590"/>
+              <a:ext cx="10855898" cy="7255344"/>
+              <a:chOff x="702365" y="200590"/>
+              <a:chExt cx="10855898" cy="7255344"/>
+            </a:xfrm>
+          </p:grpSpPr>
+          <p:pic>
+            <p:nvPicPr>
+              <p:cNvPr id="14" name="Picture 13" descr="A diagram of a mountain&#10;&#10;AI-generated content may be incorrect.">
+                <a:extLst>
+                  <a:ext uri="{FF2B5EF4-FFF2-40B4-BE49-F238E27FC236}">
+                    <a16:creationId xmlns:a16="http://schemas.microsoft.com/office/drawing/2014/main" id="{5ED8E0FE-F016-0E2C-D477-13AD495991D0}"/>
+                  </a:ext>
+                </a:extLst>
+              </p:cNvPr>
+              <p:cNvPicPr>
+                <a:picLocks noChangeAspect="1"/>
+              </p:cNvPicPr>
+              <p:nvPr/>
+            </p:nvPicPr>
+            <p:blipFill>
+              <a:blip r:embed="rId2"/>
+              <a:srcRect t="53287"/>
+              <a:stretch>
+                <a:fillRect/>
+              </a:stretch>
+            </p:blipFill>
+            <p:spPr>
+              <a:xfrm>
+                <a:off x="702365" y="3276600"/>
+                <a:ext cx="9071114" cy="2696516"/>
+              </a:xfrm>
+              <a:prstGeom prst="rect">
+                <a:avLst/>
+              </a:prstGeom>
+            </p:spPr>
+          </p:pic>
+          <p:pic>
+            <p:nvPicPr>
+              <p:cNvPr id="9" name="Picture 8" descr="A diagram of a mountain&#10;&#10;AI-generated content may be incorrect.">
+                <a:extLst>
+                  <a:ext uri="{FF2B5EF4-FFF2-40B4-BE49-F238E27FC236}">
+                    <a16:creationId xmlns:a16="http://schemas.microsoft.com/office/drawing/2014/main" id="{5321E672-6B7E-70E7-6FEC-C1A9DB76E49F}"/>
+                  </a:ext>
+                </a:extLst>
+              </p:cNvPr>
+              <p:cNvPicPr>
+                <a:picLocks noChangeAspect="1"/>
+              </p:cNvPicPr>
+              <p:nvPr/>
+            </p:nvPicPr>
+            <p:blipFill>
+              <a:blip r:embed="rId2"/>
+              <a:srcRect b="51711"/>
+              <a:stretch>
+                <a:fillRect/>
+              </a:stretch>
+            </p:blipFill>
+            <p:spPr>
+              <a:xfrm>
+                <a:off x="1205947" y="200590"/>
+                <a:ext cx="9071114" cy="2787474"/>
+              </a:xfrm>
+              <a:prstGeom prst="rect">
+                <a:avLst/>
+              </a:prstGeom>
+            </p:spPr>
+          </p:pic>
+          <p:cxnSp>
+            <p:nvCxnSpPr>
+              <p:cNvPr id="11" name="Straight Connector 10">
+                <a:extLst>
+                  <a:ext uri="{FF2B5EF4-FFF2-40B4-BE49-F238E27FC236}">
+                    <a16:creationId xmlns:a16="http://schemas.microsoft.com/office/drawing/2014/main" id="{67045C29-92EC-A4F5-905F-DDB380B4AC76}"/>
+                  </a:ext>
+                </a:extLst>
+              </p:cNvPr>
+              <p:cNvCxnSpPr>
+                <a:cxnSpLocks/>
+              </p:cNvCxnSpPr>
+              <p:nvPr/>
+            </p:nvCxnSpPr>
+            <p:spPr>
+              <a:xfrm>
+                <a:off x="5741504" y="220468"/>
+                <a:ext cx="0" cy="2575741"/>
+              </a:xfrm>
+              <a:prstGeom prst="line">
+                <a:avLst/>
+              </a:prstGeom>
+              <a:ln>
+                <a:solidFill>
+                  <a:schemeClr val="bg2">
+                    <a:lumMod val="25000"/>
+                  </a:schemeClr>
+                </a:solidFill>
+                <a:prstDash val="dash"/>
+              </a:ln>
+            </p:spPr>
+            <p:style>
+              <a:lnRef idx="2">
+                <a:schemeClr val="dk1"/>
+              </a:lnRef>
+              <a:fillRef idx="0">
+                <a:schemeClr val="dk1"/>
+              </a:fillRef>
+              <a:effectRef idx="1">
+                <a:schemeClr val="dk1"/>
+              </a:effectRef>
+              <a:fontRef idx="minor">
+                <a:schemeClr val="tx1"/>
+              </a:fontRef>
+            </p:style>
+          </p:cxnSp>
+          <p:cxnSp>
+            <p:nvCxnSpPr>
+              <p:cNvPr id="15" name="Straight Connector 14">
+                <a:extLst>
+                  <a:ext uri="{FF2B5EF4-FFF2-40B4-BE49-F238E27FC236}">
+                    <a16:creationId xmlns:a16="http://schemas.microsoft.com/office/drawing/2014/main" id="{F0E1B570-4BD7-98D4-8FBE-5262EC55B25F}"/>
+                  </a:ext>
+                </a:extLst>
+              </p:cNvPr>
+              <p:cNvCxnSpPr>
+                <a:cxnSpLocks/>
+              </p:cNvCxnSpPr>
+              <p:nvPr/>
+            </p:nvCxnSpPr>
+            <p:spPr>
+              <a:xfrm flipH="1">
+                <a:off x="755375" y="2776331"/>
+                <a:ext cx="10515600" cy="0"/>
+              </a:xfrm>
+              <a:prstGeom prst="line">
+                <a:avLst/>
+              </a:prstGeom>
+              <a:ln>
+                <a:solidFill>
+                  <a:schemeClr val="bg2">
+                    <a:lumMod val="25000"/>
+                  </a:schemeClr>
+                </a:solidFill>
+                <a:prstDash val="solid"/>
+              </a:ln>
+            </p:spPr>
+            <p:style>
+              <a:lnRef idx="2">
+                <a:schemeClr val="dk1"/>
+              </a:lnRef>
+              <a:fillRef idx="0">
+                <a:schemeClr val="dk1"/>
+              </a:fillRef>
+              <a:effectRef idx="1">
+                <a:schemeClr val="dk1"/>
+              </a:effectRef>
+              <a:fontRef idx="minor">
+                <a:schemeClr val="tx1"/>
+              </a:fontRef>
+            </p:style>
+          </p:cxnSp>
+          <p:cxnSp>
+            <p:nvCxnSpPr>
+              <p:cNvPr id="19" name="Straight Connector 18">
+                <a:extLst>
+                  <a:ext uri="{FF2B5EF4-FFF2-40B4-BE49-F238E27FC236}">
+                    <a16:creationId xmlns:a16="http://schemas.microsoft.com/office/drawing/2014/main" id="{172426A7-DC0B-4CF9-1689-ABDBFAE7BBE5}"/>
+                  </a:ext>
+                </a:extLst>
+              </p:cNvPr>
+              <p:cNvCxnSpPr>
+                <a:cxnSpLocks/>
+              </p:cNvCxnSpPr>
+              <p:nvPr/>
+            </p:nvCxnSpPr>
+            <p:spPr>
+              <a:xfrm flipH="1">
+                <a:off x="748750" y="5890592"/>
+                <a:ext cx="10515600" cy="0"/>
+              </a:xfrm>
+              <a:prstGeom prst="line">
+                <a:avLst/>
+              </a:prstGeom>
+              <a:ln>
+                <a:solidFill>
+                  <a:schemeClr val="bg2">
+                    <a:lumMod val="25000"/>
+                  </a:schemeClr>
+                </a:solidFill>
+                <a:prstDash val="solid"/>
+              </a:ln>
+            </p:spPr>
+            <p:style>
+              <a:lnRef idx="2">
+                <a:schemeClr val="dk1"/>
+              </a:lnRef>
+              <a:fillRef idx="0">
+                <a:schemeClr val="dk1"/>
+              </a:fillRef>
+              <a:effectRef idx="1">
+                <a:schemeClr val="dk1"/>
+              </a:effectRef>
+              <a:fontRef idx="minor">
+                <a:schemeClr val="tx1"/>
+              </a:fontRef>
+            </p:style>
+          </p:cxnSp>
+          <p:cxnSp>
+            <p:nvCxnSpPr>
+              <p:cNvPr id="22" name="Straight Connector 21">
+                <a:extLst>
+                  <a:ext uri="{FF2B5EF4-FFF2-40B4-BE49-F238E27FC236}">
+                    <a16:creationId xmlns:a16="http://schemas.microsoft.com/office/drawing/2014/main" id="{E82698A2-4E00-1AAE-DF08-2095CA6A48C8}"/>
+                  </a:ext>
+                </a:extLst>
+              </p:cNvPr>
+              <p:cNvCxnSpPr>
+                <a:cxnSpLocks/>
+              </p:cNvCxnSpPr>
+              <p:nvPr/>
+            </p:nvCxnSpPr>
+            <p:spPr>
+              <a:xfrm>
+                <a:off x="3985591" y="4030468"/>
+                <a:ext cx="0" cy="1860124"/>
+              </a:xfrm>
+              <a:prstGeom prst="line">
+                <a:avLst/>
+              </a:prstGeom>
+              <a:ln>
+                <a:solidFill>
+                  <a:srgbClr val="825E65"/>
+                </a:solidFill>
+                <a:prstDash val="dash"/>
+              </a:ln>
+            </p:spPr>
+            <p:style>
+              <a:lnRef idx="2">
+                <a:schemeClr val="dk1"/>
+              </a:lnRef>
+              <a:fillRef idx="0">
+                <a:schemeClr val="dk1"/>
+              </a:fillRef>
+              <a:effectRef idx="1">
+                <a:schemeClr val="dk1"/>
+              </a:effectRef>
+              <a:fontRef idx="minor">
+                <a:schemeClr val="tx1"/>
+              </a:fontRef>
+            </p:style>
+          </p:cxnSp>
+          <p:cxnSp>
+            <p:nvCxnSpPr>
+              <p:cNvPr id="24" name="Straight Connector 23">
+                <a:extLst>
+                  <a:ext uri="{FF2B5EF4-FFF2-40B4-BE49-F238E27FC236}">
+                    <a16:creationId xmlns:a16="http://schemas.microsoft.com/office/drawing/2014/main" id="{923AB6CC-F065-F0B4-4B36-BBFFB2BC594C}"/>
+                  </a:ext>
+                </a:extLst>
+              </p:cNvPr>
+              <p:cNvCxnSpPr>
+                <a:cxnSpLocks/>
+              </p:cNvCxnSpPr>
+              <p:nvPr/>
+            </p:nvCxnSpPr>
+            <p:spPr>
+              <a:xfrm>
+                <a:off x="4786173" y="4955783"/>
+                <a:ext cx="0" cy="934809"/>
+              </a:xfrm>
+              <a:prstGeom prst="line">
+                <a:avLst/>
+              </a:prstGeom>
+              <a:ln>
+                <a:solidFill>
+                  <a:srgbClr val="5B835A"/>
+                </a:solidFill>
+                <a:prstDash val="dash"/>
+              </a:ln>
+            </p:spPr>
+            <p:style>
+              <a:lnRef idx="2">
+                <a:schemeClr val="dk1"/>
+              </a:lnRef>
+              <a:fillRef idx="0">
+                <a:schemeClr val="dk1"/>
+              </a:fillRef>
+              <a:effectRef idx="1">
+                <a:schemeClr val="dk1"/>
+              </a:effectRef>
+              <a:fontRef idx="minor">
+                <a:schemeClr val="tx1"/>
+              </a:fontRef>
+            </p:style>
+          </p:cxnSp>
+          <p:cxnSp>
+            <p:nvCxnSpPr>
+              <p:cNvPr id="26" name="Straight Connector 25">
+                <a:extLst>
+                  <a:ext uri="{FF2B5EF4-FFF2-40B4-BE49-F238E27FC236}">
+                    <a16:creationId xmlns:a16="http://schemas.microsoft.com/office/drawing/2014/main" id="{0F0085C9-AB09-E7FF-124B-A9921D49F7FB}"/>
+                  </a:ext>
+                </a:extLst>
+              </p:cNvPr>
+              <p:cNvCxnSpPr>
+                <a:cxnSpLocks/>
+                <a:endCxn id="14" idx="2"/>
+              </p:cNvCxnSpPr>
+              <p:nvPr/>
+            </p:nvCxnSpPr>
+            <p:spPr>
+              <a:xfrm flipH="1">
+                <a:off x="5237922" y="3417425"/>
+                <a:ext cx="1593" cy="2555691"/>
+              </a:xfrm>
+              <a:prstGeom prst="line">
+                <a:avLst/>
+              </a:prstGeom>
+              <a:ln>
+                <a:solidFill>
+                  <a:srgbClr val="E1795D"/>
+                </a:solidFill>
+                <a:prstDash val="dash"/>
+              </a:ln>
+            </p:spPr>
+            <p:style>
+              <a:lnRef idx="2">
+                <a:schemeClr val="dk1"/>
+              </a:lnRef>
+              <a:fillRef idx="0">
+                <a:schemeClr val="dk1"/>
+              </a:fillRef>
+              <a:effectRef idx="1">
+                <a:schemeClr val="dk1"/>
+              </a:effectRef>
+              <a:fontRef idx="minor">
+                <a:schemeClr val="tx1"/>
+              </a:fontRef>
+            </p:style>
+          </p:cxnSp>
+          <p:cxnSp>
+            <p:nvCxnSpPr>
+              <p:cNvPr id="28" name="Straight Connector 27">
+                <a:extLst>
+                  <a:ext uri="{FF2B5EF4-FFF2-40B4-BE49-F238E27FC236}">
+                    <a16:creationId xmlns:a16="http://schemas.microsoft.com/office/drawing/2014/main" id="{1B1CC2F2-DE08-F6AA-84BB-A48D210BD97D}"/>
+                  </a:ext>
+                </a:extLst>
+              </p:cNvPr>
+              <p:cNvCxnSpPr>
+                <a:cxnSpLocks/>
+              </p:cNvCxnSpPr>
+              <p:nvPr/>
+            </p:nvCxnSpPr>
+            <p:spPr>
+              <a:xfrm>
+                <a:off x="5565535" y="4368478"/>
+                <a:ext cx="0" cy="1522114"/>
+              </a:xfrm>
+              <a:prstGeom prst="line">
+                <a:avLst/>
+              </a:prstGeom>
+              <a:ln>
+                <a:solidFill>
+                  <a:srgbClr val="467C9D"/>
+                </a:solidFill>
+                <a:prstDash val="dash"/>
+              </a:ln>
+            </p:spPr>
+            <p:style>
+              <a:lnRef idx="2">
+                <a:schemeClr val="dk1"/>
+              </a:lnRef>
+              <a:fillRef idx="0">
+                <a:schemeClr val="dk1"/>
+              </a:fillRef>
+              <a:effectRef idx="1">
+                <a:schemeClr val="dk1"/>
+              </a:effectRef>
+              <a:fontRef idx="minor">
+                <a:schemeClr val="tx1"/>
+              </a:fontRef>
+            </p:style>
+          </p:cxnSp>
+          <p:cxnSp>
+            <p:nvCxnSpPr>
+              <p:cNvPr id="30" name="Straight Connector 29">
+                <a:extLst>
+                  <a:ext uri="{FF2B5EF4-FFF2-40B4-BE49-F238E27FC236}">
+                    <a16:creationId xmlns:a16="http://schemas.microsoft.com/office/drawing/2014/main" id="{CB39B40C-4576-1F00-C3DF-2B126298368E}"/>
+                  </a:ext>
+                </a:extLst>
+              </p:cNvPr>
+              <p:cNvCxnSpPr>
+                <a:cxnSpLocks/>
+              </p:cNvCxnSpPr>
+              <p:nvPr/>
+            </p:nvCxnSpPr>
+            <p:spPr>
+              <a:xfrm>
+                <a:off x="6910127" y="5101638"/>
+                <a:ext cx="0" cy="788954"/>
+              </a:xfrm>
+              <a:prstGeom prst="line">
+                <a:avLst/>
+              </a:prstGeom>
+              <a:ln>
+                <a:solidFill>
+                  <a:srgbClr val="F6BD5F"/>
+                </a:solidFill>
+                <a:prstDash val="dash"/>
+              </a:ln>
+            </p:spPr>
+            <p:style>
+              <a:lnRef idx="2">
+                <a:schemeClr val="dk1"/>
+              </a:lnRef>
+              <a:fillRef idx="0">
+                <a:schemeClr val="dk1"/>
+              </a:fillRef>
+              <a:effectRef idx="1">
+                <a:schemeClr val="dk1"/>
+              </a:effectRef>
+              <a:fontRef idx="minor">
+                <a:schemeClr val="tx1"/>
+              </a:fontRef>
+            </p:style>
+          </p:cxnSp>
+          <mc:AlternateContent xmlns:mc="http://schemas.openxmlformats.org/markup-compatibility/2006">
+            <mc:Choice xmlns:a14="http://schemas.microsoft.com/office/drawing/2010/main" Requires="a14">
+              <p:sp>
+                <p:nvSpPr>
+                  <p:cNvPr id="32" name="TextBox 31">
+                    <a:extLst>
+                      <a:ext uri="{FF2B5EF4-FFF2-40B4-BE49-F238E27FC236}">
+                        <a16:creationId xmlns:a16="http://schemas.microsoft.com/office/drawing/2014/main" id="{0A2BC88F-3C6D-065B-B01C-D2416EF5E913}"/>
+                      </a:ext>
+                    </a:extLst>
+                  </p:cNvPr>
+                  <p:cNvSpPr txBox="1"/>
+                  <p:nvPr/>
+                </p:nvSpPr>
+                <p:spPr>
+                  <a:xfrm>
+                    <a:off x="5783305" y="2366970"/>
+                    <a:ext cx="340950" cy="307777"/>
+                  </a:xfrm>
+                  <a:prstGeom prst="rect">
+                    <a:avLst/>
+                  </a:prstGeom>
+                  <a:noFill/>
+                </p:spPr>
+                <p:txBody>
+                  <a:bodyPr wrap="square" lIns="0" tIns="0" rIns="0" bIns="0" rtlCol="0">
+                    <a:spAutoFit/>
+                  </a:bodyPr>
+                  <a:lstStyle/>
+                  <a:p>
+                    <a14:m>
+                      <m:oMathPara xmlns:m="http://schemas.openxmlformats.org/officeDocument/2006/math">
+                        <m:oMathParaPr>
+                          <m:jc m:val="centerGroup"/>
+                        </m:oMathParaPr>
+                        <m:oMath xmlns:m="http://schemas.openxmlformats.org/officeDocument/2006/math">
+                          <m:r>
+                            <a:rPr lang="en-US" sz="2000" b="1" i="1" smtClean="0">
+                              <a:solidFill>
+                                <a:schemeClr val="tx1">
+                                  <a:lumMod val="65000"/>
+                                  <a:lumOff val="35000"/>
+                                </a:schemeClr>
+                              </a:solidFill>
+                              <a:latin typeface="Cambria Math" panose="02040503050406030204" pitchFamily="18" charset="0"/>
+                            </a:rPr>
+                            <m:t>𝝁</m:t>
+                          </m:r>
+                        </m:oMath>
+                      </m:oMathPara>
+                    </a14:m>
+                    <a:endParaRPr lang="en-US" sz="2000" b="1" dirty="0">
+                      <a:solidFill>
+                        <a:schemeClr val="tx1">
+                          <a:lumMod val="65000"/>
+                          <a:lumOff val="35000"/>
+                        </a:schemeClr>
+                      </a:solidFill>
+                    </a:endParaRPr>
+                  </a:p>
+                </p:txBody>
+              </p:sp>
+            </mc:Choice>
+            <mc:Fallback>
+              <p:sp>
+                <p:nvSpPr>
+                  <p:cNvPr id="32" name="TextBox 31">
+                    <a:extLst>
+                      <a:ext uri="{FF2B5EF4-FFF2-40B4-BE49-F238E27FC236}">
+                        <a16:creationId xmlns:a16="http://schemas.microsoft.com/office/drawing/2014/main" id="{0A2BC88F-3C6D-065B-B01C-D2416EF5E913}"/>
+                      </a:ext>
+                    </a:extLst>
+                  </p:cNvPr>
+                  <p:cNvSpPr txBox="1">
+                    <a:spLocks noRot="1" noChangeAspect="1" noMove="1" noResize="1" noEditPoints="1" noAdjustHandles="1" noChangeArrowheads="1" noChangeShapeType="1" noTextEdit="1"/>
+                  </p:cNvSpPr>
+                  <p:nvPr/>
+                </p:nvSpPr>
+                <p:spPr>
+                  <a:xfrm>
+                    <a:off x="5783305" y="2366970"/>
+                    <a:ext cx="340950" cy="307777"/>
+                  </a:xfrm>
+                  <a:prstGeom prst="rect">
+                    <a:avLst/>
+                  </a:prstGeom>
+                  <a:blipFill>
+                    <a:blip r:embed="rId3"/>
+                    <a:stretch>
+                      <a:fillRect b="-24000"/>
+                    </a:stretch>
+                  </a:blipFill>
+                </p:spPr>
+                <p:txBody>
+                  <a:bodyPr/>
+                  <a:lstStyle/>
+                  <a:p>
+                    <a:r>
+                      <a:rPr lang="en-US">
+                        <a:noFill/>
+                      </a:rPr>
+                      <a:t> </a:t>
+                    </a:r>
+                  </a:p>
+                </p:txBody>
+              </p:sp>
+            </mc:Fallback>
+          </mc:AlternateContent>
+          <p:sp>
+            <p:nvSpPr>
+              <p:cNvPr id="35" name="TextBox 34">
+                <a:extLst>
+                  <a:ext uri="{FF2B5EF4-FFF2-40B4-BE49-F238E27FC236}">
+                    <a16:creationId xmlns:a16="http://schemas.microsoft.com/office/drawing/2014/main" id="{5FA129F4-AB94-94E2-20E3-7D317EC82773}"/>
+                  </a:ext>
+                </a:extLst>
+              </p:cNvPr>
+              <p:cNvSpPr txBox="1"/>
+              <p:nvPr/>
+            </p:nvSpPr>
+            <p:spPr>
+              <a:xfrm>
+                <a:off x="9290958" y="2301133"/>
+                <a:ext cx="2267305" cy="369332"/>
+              </a:xfrm>
+              <a:prstGeom prst="rect">
+                <a:avLst/>
+              </a:prstGeom>
+              <a:noFill/>
+            </p:spPr>
+            <p:txBody>
+              <a:bodyPr wrap="square" rtlCol="0">
+                <a:spAutoFit/>
+              </a:bodyPr>
+              <a:lstStyle/>
+              <a:p>
+                <a:r>
+                  <a:rPr lang="en-US" b="1" dirty="0" err="1">
+                    <a:latin typeface="Aptos Light" panose="020B0004020202020204" pitchFamily="34" charset="0"/>
+                  </a:rPr>
+                  <a:t>Nível</a:t>
+                </a:r>
+                <a:r>
+                  <a:rPr lang="en-US" b="1" dirty="0">
+                    <a:latin typeface="Aptos Light" panose="020B0004020202020204" pitchFamily="34" charset="0"/>
+                  </a:rPr>
+                  <a:t> </a:t>
+                </a:r>
+                <a:r>
+                  <a:rPr lang="en-US" b="1" dirty="0" err="1">
+                    <a:latin typeface="Aptos Light" panose="020B0004020202020204" pitchFamily="34" charset="0"/>
+                  </a:rPr>
+                  <a:t>populacional</a:t>
+                </a:r>
+                <a:endParaRPr lang="en-US" b="1" dirty="0">
+                  <a:latin typeface="Aptos Light" panose="020B0004020202020204" pitchFamily="34" charset="0"/>
+                </a:endParaRPr>
+              </a:p>
+            </p:txBody>
+          </p:sp>
+          <mc:AlternateContent xmlns:mc="http://schemas.openxmlformats.org/markup-compatibility/2006">
+            <mc:Choice xmlns:a14="http://schemas.microsoft.com/office/drawing/2010/main" Requires="a14">
+              <p:sp>
+                <p:nvSpPr>
+                  <p:cNvPr id="37" name="TextBox 36">
+                    <a:extLst>
+                      <a:ext uri="{FF2B5EF4-FFF2-40B4-BE49-F238E27FC236}">
+                        <a16:creationId xmlns:a16="http://schemas.microsoft.com/office/drawing/2014/main" id="{87E44ED8-AF6B-526B-F1CF-CF37C6B581F1}"/>
+                      </a:ext>
+                    </a:extLst>
+                  </p:cNvPr>
+                  <p:cNvSpPr txBox="1"/>
+                  <p:nvPr/>
+                </p:nvSpPr>
+                <p:spPr>
+                  <a:xfrm>
+                    <a:off x="3836537" y="6623874"/>
+                    <a:ext cx="340950" cy="615553"/>
+                  </a:xfrm>
+                  <a:prstGeom prst="rect">
+                    <a:avLst/>
+                  </a:prstGeom>
+                  <a:noFill/>
+                </p:spPr>
+                <p:txBody>
+                  <a:bodyPr wrap="square" lIns="0" tIns="0" rIns="0" bIns="0" rtlCol="0">
+                    <a:spAutoFit/>
+                  </a:bodyPr>
+                  <a:lstStyle/>
+                  <a:p>
+                    <a14:m>
+                      <m:oMathPara xmlns:m="http://schemas.openxmlformats.org/officeDocument/2006/math">
+                        <m:oMathParaPr>
+                          <m:jc m:val="centerGroup"/>
+                        </m:oMathParaPr>
+                        <m:oMath xmlns:m="http://schemas.openxmlformats.org/officeDocument/2006/math">
+                          <m:sSub>
+                            <m:sSubPr>
+                              <m:ctrlPr>
+                                <a:rPr lang="en-US" sz="2000" b="1" i="1" smtClean="0">
+                                  <a:solidFill>
+                                    <a:srgbClr val="825E65"/>
+                                  </a:solidFill>
+                                  <a:latin typeface="Cambria Math" panose="02040503050406030204" pitchFamily="18" charset="0"/>
+                                </a:rPr>
+                              </m:ctrlPr>
+                            </m:sSubPr>
+                            <m:e>
+                              <m:r>
+                                <a:rPr lang="en-US" sz="2000" b="1" i="1" smtClean="0">
+                                  <a:solidFill>
+                                    <a:srgbClr val="825E65"/>
+                                  </a:solidFill>
+                                  <a:latin typeface="Cambria Math" panose="02040503050406030204" pitchFamily="18" charset="0"/>
+                                </a:rPr>
+                                <m:t>𝝁</m:t>
+                              </m:r>
+                            </m:e>
+                            <m:sub>
+                              <m:r>
+                                <a:rPr lang="en-US" sz="2000" b="1" i="1" smtClean="0">
+                                  <a:solidFill>
+                                    <a:srgbClr val="825E65"/>
+                                  </a:solidFill>
+                                  <a:latin typeface="Cambria Math" panose="02040503050406030204" pitchFamily="18" charset="0"/>
+                                </a:rPr>
+                                <m:t>𝑨</m:t>
+                              </m:r>
+                            </m:sub>
+                          </m:sSub>
+                        </m:oMath>
+                      </m:oMathPara>
+                    </a14:m>
+                    <a:endParaRPr lang="en-US" sz="2000" b="1" dirty="0">
+                      <a:solidFill>
+                        <a:srgbClr val="825E65"/>
+                      </a:solidFill>
+                    </a:endParaRPr>
+                  </a:p>
+                  <a:p>
+                    <a:endParaRPr lang="en-US" sz="2000" b="1" dirty="0">
+                      <a:solidFill>
+                        <a:srgbClr val="825E65"/>
+                      </a:solidFill>
+                    </a:endParaRPr>
+                  </a:p>
+                </p:txBody>
+              </p:sp>
+            </mc:Choice>
+            <mc:Fallback>
+              <p:sp>
+                <p:nvSpPr>
+                  <p:cNvPr id="37" name="TextBox 36">
+                    <a:extLst>
+                      <a:ext uri="{FF2B5EF4-FFF2-40B4-BE49-F238E27FC236}">
+                        <a16:creationId xmlns:a16="http://schemas.microsoft.com/office/drawing/2014/main" id="{87E44ED8-AF6B-526B-F1CF-CF37C6B581F1}"/>
+                      </a:ext>
+                    </a:extLst>
+                  </p:cNvPr>
+                  <p:cNvSpPr txBox="1">
+                    <a:spLocks noRot="1" noChangeAspect="1" noMove="1" noResize="1" noEditPoints="1" noAdjustHandles="1" noChangeArrowheads="1" noChangeShapeType="1" noTextEdit="1"/>
+                  </p:cNvSpPr>
+                  <p:nvPr/>
+                </p:nvSpPr>
+                <p:spPr>
+                  <a:xfrm>
+                    <a:off x="3836537" y="6623874"/>
+                    <a:ext cx="340950" cy="615553"/>
+                  </a:xfrm>
+                  <a:prstGeom prst="rect">
+                    <a:avLst/>
+                  </a:prstGeom>
+                  <a:blipFill>
+                    <a:blip r:embed="rId4"/>
+                    <a:stretch>
+                      <a:fillRect l="-17857" r="-10714"/>
+                    </a:stretch>
+                  </a:blipFill>
+                </p:spPr>
+                <p:txBody>
+                  <a:bodyPr/>
+                  <a:lstStyle/>
+                  <a:p>
+                    <a:r>
+                      <a:rPr lang="en-US">
+                        <a:noFill/>
+                      </a:rPr>
+                      <a:t> </a:t>
+                    </a:r>
+                  </a:p>
+                </p:txBody>
+              </p:sp>
+            </mc:Fallback>
+          </mc:AlternateContent>
+          <mc:AlternateContent xmlns:mc="http://schemas.openxmlformats.org/markup-compatibility/2006">
+            <mc:Choice xmlns:a14="http://schemas.microsoft.com/office/drawing/2010/main" Requires="a14">
+              <p:sp>
+                <p:nvSpPr>
+                  <p:cNvPr id="38" name="TextBox 37">
+                    <a:extLst>
+                      <a:ext uri="{FF2B5EF4-FFF2-40B4-BE49-F238E27FC236}">
+                        <a16:creationId xmlns:a16="http://schemas.microsoft.com/office/drawing/2014/main" id="{A92EFDDF-E56A-B371-CBF7-2620662D30D8}"/>
+                      </a:ext>
+                    </a:extLst>
+                  </p:cNvPr>
+                  <p:cNvSpPr txBox="1"/>
+                  <p:nvPr/>
+                </p:nvSpPr>
+                <p:spPr>
+                  <a:xfrm>
+                    <a:off x="4637119" y="6628678"/>
+                    <a:ext cx="340950" cy="615553"/>
+                  </a:xfrm>
+                  <a:prstGeom prst="rect">
+                    <a:avLst/>
+                  </a:prstGeom>
+                  <a:noFill/>
+                </p:spPr>
+                <p:txBody>
+                  <a:bodyPr wrap="square" lIns="0" tIns="0" rIns="0" bIns="0" rtlCol="0">
+                    <a:spAutoFit/>
+                  </a:bodyPr>
+                  <a:lstStyle/>
+                  <a:p>
+                    <a14:m>
+                      <m:oMathPara xmlns:m="http://schemas.openxmlformats.org/officeDocument/2006/math">
+                        <m:oMathParaPr>
+                          <m:jc m:val="centerGroup"/>
+                        </m:oMathParaPr>
+                        <m:oMath xmlns:m="http://schemas.openxmlformats.org/officeDocument/2006/math">
+                          <m:sSub>
+                            <m:sSubPr>
+                              <m:ctrlPr>
+                                <a:rPr lang="en-US" sz="2000" b="1" i="1" smtClean="0">
+                                  <a:solidFill>
+                                    <a:srgbClr val="5B835A"/>
+                                  </a:solidFill>
+                                  <a:latin typeface="Cambria Math" panose="02040503050406030204" pitchFamily="18" charset="0"/>
+                                </a:rPr>
+                              </m:ctrlPr>
+                            </m:sSubPr>
+                            <m:e>
+                              <m:r>
+                                <a:rPr lang="en-US" sz="2000" b="1" i="1" smtClean="0">
+                                  <a:solidFill>
+                                    <a:srgbClr val="5B835A"/>
+                                  </a:solidFill>
+                                  <a:latin typeface="Cambria Math" panose="02040503050406030204" pitchFamily="18" charset="0"/>
+                                </a:rPr>
+                                <m:t>𝝁</m:t>
+                              </m:r>
+                            </m:e>
+                            <m:sub>
+                              <m:r>
+                                <m:rPr>
+                                  <m:sty m:val="p"/>
+                                </m:rPr>
+                                <a:rPr lang="en-US" sz="2000" b="1" i="1" smtClean="0">
+                                  <a:solidFill>
+                                    <a:srgbClr val="5B835A"/>
+                                  </a:solidFill>
+                                  <a:latin typeface="Cambria Math" panose="02040503050406030204" pitchFamily="18" charset="0"/>
+                                </a:rPr>
+                                <m:t>B</m:t>
+                              </m:r>
+                            </m:sub>
+                          </m:sSub>
+                        </m:oMath>
+                      </m:oMathPara>
+                    </a14:m>
+                    <a:endParaRPr lang="en-US" sz="2000" b="1" dirty="0">
+                      <a:solidFill>
+                        <a:srgbClr val="5B835A"/>
+                      </a:solidFill>
+                    </a:endParaRPr>
+                  </a:p>
+                  <a:p>
+                    <a:endParaRPr lang="en-US" sz="2000" b="1" dirty="0">
+                      <a:solidFill>
+                        <a:srgbClr val="5B835A"/>
+                      </a:solidFill>
+                    </a:endParaRPr>
+                  </a:p>
+                </p:txBody>
+              </p:sp>
+            </mc:Choice>
+            <mc:Fallback>
+              <p:sp>
+                <p:nvSpPr>
+                  <p:cNvPr id="38" name="TextBox 37">
+                    <a:extLst>
+                      <a:ext uri="{FF2B5EF4-FFF2-40B4-BE49-F238E27FC236}">
+                        <a16:creationId xmlns:a16="http://schemas.microsoft.com/office/drawing/2014/main" id="{A92EFDDF-E56A-B371-CBF7-2620662D30D8}"/>
+                      </a:ext>
+                    </a:extLst>
+                  </p:cNvPr>
+                  <p:cNvSpPr txBox="1">
+                    <a:spLocks noRot="1" noChangeAspect="1" noMove="1" noResize="1" noEditPoints="1" noAdjustHandles="1" noChangeArrowheads="1" noChangeShapeType="1" noTextEdit="1"/>
+                  </p:cNvSpPr>
+                  <p:nvPr/>
+                </p:nvSpPr>
+                <p:spPr>
+                  <a:xfrm>
+                    <a:off x="4637119" y="6628678"/>
+                    <a:ext cx="340950" cy="615553"/>
+                  </a:xfrm>
+                  <a:prstGeom prst="rect">
+                    <a:avLst/>
+                  </a:prstGeom>
+                  <a:blipFill>
+                    <a:blip r:embed="rId5"/>
+                    <a:stretch>
+                      <a:fillRect l="-21429" r="-7143"/>
+                    </a:stretch>
+                  </a:blipFill>
+                </p:spPr>
+                <p:txBody>
+                  <a:bodyPr/>
+                  <a:lstStyle/>
+                  <a:p>
+                    <a:r>
+                      <a:rPr lang="en-US">
+                        <a:noFill/>
+                      </a:rPr>
+                      <a:t> </a:t>
+                    </a:r>
+                  </a:p>
+                </p:txBody>
+              </p:sp>
+            </mc:Fallback>
+          </mc:AlternateContent>
+          <mc:AlternateContent xmlns:mc="http://schemas.openxmlformats.org/markup-compatibility/2006">
+            <mc:Choice xmlns:a14="http://schemas.microsoft.com/office/drawing/2010/main" Requires="a14">
+              <p:sp>
+                <p:nvSpPr>
+                  <p:cNvPr id="39" name="TextBox 38">
+                    <a:extLst>
+                      <a:ext uri="{FF2B5EF4-FFF2-40B4-BE49-F238E27FC236}">
+                        <a16:creationId xmlns:a16="http://schemas.microsoft.com/office/drawing/2014/main" id="{21FD1E90-CE2C-A1C6-6E5E-E509841F6E75}"/>
+                      </a:ext>
+                    </a:extLst>
+                  </p:cNvPr>
+                  <p:cNvSpPr txBox="1"/>
+                  <p:nvPr/>
+                </p:nvSpPr>
+                <p:spPr>
+                  <a:xfrm>
+                    <a:off x="5072491" y="6652480"/>
+                    <a:ext cx="340950" cy="615553"/>
+                  </a:xfrm>
+                  <a:prstGeom prst="rect">
+                    <a:avLst/>
+                  </a:prstGeom>
+                  <a:noFill/>
+                </p:spPr>
+                <p:txBody>
+                  <a:bodyPr wrap="square" lIns="0" tIns="0" rIns="0" bIns="0" rtlCol="0">
+                    <a:spAutoFit/>
+                  </a:bodyPr>
+                  <a:lstStyle/>
+                  <a:p>
+                    <a14:m>
+                      <m:oMathPara xmlns:m="http://schemas.openxmlformats.org/officeDocument/2006/math">
+                        <m:oMathParaPr>
+                          <m:jc m:val="centerGroup"/>
+                        </m:oMathParaPr>
+                        <m:oMath xmlns:m="http://schemas.openxmlformats.org/officeDocument/2006/math">
+                          <m:sSub>
+                            <m:sSubPr>
+                              <m:ctrlPr>
+                                <a:rPr lang="en-US" sz="2000" b="1" i="1" smtClean="0">
+                                  <a:solidFill>
+                                    <a:srgbClr val="E1795D"/>
+                                  </a:solidFill>
+                                  <a:latin typeface="Cambria Math" panose="02040503050406030204" pitchFamily="18" charset="0"/>
+                                </a:rPr>
+                              </m:ctrlPr>
+                            </m:sSubPr>
+                            <m:e>
+                              <m:r>
+                                <a:rPr lang="en-US" sz="2000" b="1" i="1" smtClean="0">
+                                  <a:solidFill>
+                                    <a:srgbClr val="E1795D"/>
+                                  </a:solidFill>
+                                  <a:latin typeface="Cambria Math" panose="02040503050406030204" pitchFamily="18" charset="0"/>
+                                </a:rPr>
+                                <m:t>𝝁</m:t>
+                              </m:r>
+                            </m:e>
+                            <m:sub>
+                              <m:r>
+                                <m:rPr>
+                                  <m:sty m:val="p"/>
+                                </m:rPr>
+                                <a:rPr lang="en-US" sz="2000" b="1" i="1" smtClean="0">
+                                  <a:solidFill>
+                                    <a:srgbClr val="E1795D"/>
+                                  </a:solidFill>
+                                  <a:latin typeface="Cambria Math" panose="02040503050406030204" pitchFamily="18" charset="0"/>
+                                </a:rPr>
+                                <m:t>C</m:t>
+                              </m:r>
+                            </m:sub>
+                          </m:sSub>
+                        </m:oMath>
+                      </m:oMathPara>
+                    </a14:m>
+                    <a:endParaRPr lang="en-US" sz="2000" b="1" dirty="0">
+                      <a:solidFill>
+                        <a:srgbClr val="E1795D"/>
+                      </a:solidFill>
+                    </a:endParaRPr>
+                  </a:p>
+                  <a:p>
+                    <a:endParaRPr lang="en-US" sz="2000" b="1" dirty="0">
+                      <a:solidFill>
+                        <a:srgbClr val="E1795D"/>
+                      </a:solidFill>
+                    </a:endParaRPr>
+                  </a:p>
+                </p:txBody>
+              </p:sp>
+            </mc:Choice>
+            <mc:Fallback>
+              <p:sp>
+                <p:nvSpPr>
+                  <p:cNvPr id="39" name="TextBox 38">
+                    <a:extLst>
+                      <a:ext uri="{FF2B5EF4-FFF2-40B4-BE49-F238E27FC236}">
+                        <a16:creationId xmlns:a16="http://schemas.microsoft.com/office/drawing/2014/main" id="{21FD1E90-CE2C-A1C6-6E5E-E509841F6E75}"/>
+                      </a:ext>
+                    </a:extLst>
+                  </p:cNvPr>
+                  <p:cNvSpPr txBox="1">
+                    <a:spLocks noRot="1" noChangeAspect="1" noMove="1" noResize="1" noEditPoints="1" noAdjustHandles="1" noChangeArrowheads="1" noChangeShapeType="1" noTextEdit="1"/>
+                  </p:cNvSpPr>
+                  <p:nvPr/>
+                </p:nvSpPr>
+                <p:spPr>
+                  <a:xfrm>
+                    <a:off x="5072491" y="6652480"/>
+                    <a:ext cx="340950" cy="615553"/>
+                  </a:xfrm>
+                  <a:prstGeom prst="rect">
+                    <a:avLst/>
+                  </a:prstGeom>
+                  <a:blipFill>
+                    <a:blip r:embed="rId6"/>
+                    <a:stretch>
+                      <a:fillRect l="-17857" r="-7143"/>
+                    </a:stretch>
+                  </a:blipFill>
+                </p:spPr>
+                <p:txBody>
+                  <a:bodyPr/>
+                  <a:lstStyle/>
+                  <a:p>
+                    <a:r>
+                      <a:rPr lang="en-US">
+                        <a:noFill/>
+                      </a:rPr>
+                      <a:t> </a:t>
+                    </a:r>
+                  </a:p>
+                </p:txBody>
+              </p:sp>
+            </mc:Fallback>
+          </mc:AlternateContent>
+          <mc:AlternateContent xmlns:mc="http://schemas.openxmlformats.org/markup-compatibility/2006">
+            <mc:Choice xmlns:a14="http://schemas.microsoft.com/office/drawing/2010/main" Requires="a14">
+              <p:sp>
+                <p:nvSpPr>
+                  <p:cNvPr id="40" name="TextBox 39">
+                    <a:extLst>
+                      <a:ext uri="{FF2B5EF4-FFF2-40B4-BE49-F238E27FC236}">
+                        <a16:creationId xmlns:a16="http://schemas.microsoft.com/office/drawing/2014/main" id="{7487E948-ECD6-6666-D485-3BA0A2967403}"/>
+                      </a:ext>
+                    </a:extLst>
+                  </p:cNvPr>
+                  <p:cNvSpPr txBox="1"/>
+                  <p:nvPr/>
+                </p:nvSpPr>
+                <p:spPr>
+                  <a:xfrm>
+                    <a:off x="5457621" y="6651727"/>
+                    <a:ext cx="340950" cy="615553"/>
+                  </a:xfrm>
+                  <a:prstGeom prst="rect">
+                    <a:avLst/>
+                  </a:prstGeom>
+                  <a:noFill/>
+                </p:spPr>
+                <p:txBody>
+                  <a:bodyPr wrap="square" lIns="0" tIns="0" rIns="0" bIns="0" rtlCol="0">
+                    <a:spAutoFit/>
+                  </a:bodyPr>
+                  <a:lstStyle/>
+                  <a:p>
+                    <a14:m>
+                      <m:oMathPara xmlns:m="http://schemas.openxmlformats.org/officeDocument/2006/math">
+                        <m:oMathParaPr>
+                          <m:jc m:val="centerGroup"/>
+                        </m:oMathParaPr>
+                        <m:oMath xmlns:m="http://schemas.openxmlformats.org/officeDocument/2006/math">
+                          <m:sSub>
+                            <m:sSubPr>
+                              <m:ctrlPr>
+                                <a:rPr lang="en-US" sz="2000" b="1" i="1" smtClean="0">
+                                  <a:solidFill>
+                                    <a:srgbClr val="467C9D"/>
+                                  </a:solidFill>
+                                  <a:latin typeface="Cambria Math" panose="02040503050406030204" pitchFamily="18" charset="0"/>
+                                </a:rPr>
+                              </m:ctrlPr>
+                            </m:sSubPr>
+                            <m:e>
+                              <m:r>
+                                <a:rPr lang="en-US" sz="2000" b="1" i="1" smtClean="0">
+                                  <a:solidFill>
+                                    <a:srgbClr val="467C9D"/>
+                                  </a:solidFill>
+                                  <a:latin typeface="Cambria Math" panose="02040503050406030204" pitchFamily="18" charset="0"/>
+                                </a:rPr>
+                                <m:t>𝝁</m:t>
+                              </m:r>
+                            </m:e>
+                            <m:sub>
+                              <m:r>
+                                <m:rPr>
+                                  <m:sty m:val="p"/>
+                                </m:rPr>
+                                <a:rPr lang="en-US" sz="2000" b="1" i="1" smtClean="0">
+                                  <a:solidFill>
+                                    <a:srgbClr val="467C9D"/>
+                                  </a:solidFill>
+                                  <a:latin typeface="Cambria Math" panose="02040503050406030204" pitchFamily="18" charset="0"/>
+                                </a:rPr>
+                                <m:t>D</m:t>
+                              </m:r>
+                            </m:sub>
+                          </m:sSub>
+                        </m:oMath>
+                      </m:oMathPara>
+                    </a14:m>
+                    <a:endParaRPr lang="en-US" sz="2000" b="1" dirty="0">
+                      <a:solidFill>
+                        <a:srgbClr val="467C9D"/>
+                      </a:solidFill>
+                    </a:endParaRPr>
+                  </a:p>
+                  <a:p>
+                    <a:endParaRPr lang="en-US" sz="2000" b="1" dirty="0">
+                      <a:solidFill>
+                        <a:srgbClr val="467C9D"/>
+                      </a:solidFill>
+                    </a:endParaRPr>
+                  </a:p>
+                </p:txBody>
+              </p:sp>
+            </mc:Choice>
+            <mc:Fallback>
+              <p:sp>
+                <p:nvSpPr>
+                  <p:cNvPr id="40" name="TextBox 39">
+                    <a:extLst>
+                      <a:ext uri="{FF2B5EF4-FFF2-40B4-BE49-F238E27FC236}">
+                        <a16:creationId xmlns:a16="http://schemas.microsoft.com/office/drawing/2014/main" id="{7487E948-ECD6-6666-D485-3BA0A2967403}"/>
+                      </a:ext>
+                    </a:extLst>
+                  </p:cNvPr>
+                  <p:cNvSpPr txBox="1">
+                    <a:spLocks noRot="1" noChangeAspect="1" noMove="1" noResize="1" noEditPoints="1" noAdjustHandles="1" noChangeArrowheads="1" noChangeShapeType="1" noTextEdit="1"/>
+                  </p:cNvSpPr>
+                  <p:nvPr/>
+                </p:nvSpPr>
+                <p:spPr>
+                  <a:xfrm>
+                    <a:off x="5457621" y="6651727"/>
+                    <a:ext cx="340950" cy="615553"/>
+                  </a:xfrm>
+                  <a:prstGeom prst="rect">
+                    <a:avLst/>
+                  </a:prstGeom>
+                  <a:blipFill>
+                    <a:blip r:embed="rId7"/>
+                    <a:stretch>
+                      <a:fillRect l="-21429" r="-10714"/>
+                    </a:stretch>
+                  </a:blipFill>
+                </p:spPr>
+                <p:txBody>
+                  <a:bodyPr/>
+                  <a:lstStyle/>
+                  <a:p>
+                    <a:r>
+                      <a:rPr lang="en-US">
+                        <a:noFill/>
+                      </a:rPr>
+                      <a:t> </a:t>
+                    </a:r>
+                  </a:p>
+                </p:txBody>
+              </p:sp>
+            </mc:Fallback>
+          </mc:AlternateContent>
+          <mc:AlternateContent xmlns:mc="http://schemas.openxmlformats.org/markup-compatibility/2006">
+            <mc:Choice xmlns:a14="http://schemas.microsoft.com/office/drawing/2010/main" Requires="a14">
+              <p:sp>
+                <p:nvSpPr>
+                  <p:cNvPr id="41" name="TextBox 40">
+                    <a:extLst>
+                      <a:ext uri="{FF2B5EF4-FFF2-40B4-BE49-F238E27FC236}">
+                        <a16:creationId xmlns:a16="http://schemas.microsoft.com/office/drawing/2014/main" id="{93DFD1D4-1004-FECC-F7F5-719B3280A53F}"/>
+                      </a:ext>
+                    </a:extLst>
+                  </p:cNvPr>
+                  <p:cNvSpPr txBox="1"/>
+                  <p:nvPr/>
+                </p:nvSpPr>
+                <p:spPr>
+                  <a:xfrm>
+                    <a:off x="6761073" y="6651727"/>
+                    <a:ext cx="340950" cy="615553"/>
+                  </a:xfrm>
+                  <a:prstGeom prst="rect">
+                    <a:avLst/>
+                  </a:prstGeom>
+                  <a:noFill/>
+                </p:spPr>
+                <p:txBody>
+                  <a:bodyPr wrap="square" lIns="0" tIns="0" rIns="0" bIns="0" rtlCol="0">
+                    <a:spAutoFit/>
+                  </a:bodyPr>
+                  <a:lstStyle/>
+                  <a:p>
+                    <a14:m>
+                      <m:oMathPara xmlns:m="http://schemas.openxmlformats.org/officeDocument/2006/math">
+                        <m:oMathParaPr>
+                          <m:jc m:val="centerGroup"/>
+                        </m:oMathParaPr>
+                        <m:oMath xmlns:m="http://schemas.openxmlformats.org/officeDocument/2006/math">
+                          <m:sSub>
+                            <m:sSubPr>
+                              <m:ctrlPr>
+                                <a:rPr lang="en-US" sz="2000" b="1" i="1" smtClean="0">
+                                  <a:solidFill>
+                                    <a:srgbClr val="F6BD5F"/>
+                                  </a:solidFill>
+                                  <a:latin typeface="Cambria Math" panose="02040503050406030204" pitchFamily="18" charset="0"/>
+                                </a:rPr>
+                              </m:ctrlPr>
+                            </m:sSubPr>
+                            <m:e>
+                              <m:r>
+                                <a:rPr lang="en-US" sz="2000" b="1" i="1" smtClean="0">
+                                  <a:solidFill>
+                                    <a:srgbClr val="F6BD5F"/>
+                                  </a:solidFill>
+                                  <a:latin typeface="Cambria Math" panose="02040503050406030204" pitchFamily="18" charset="0"/>
+                                </a:rPr>
+                                <m:t>𝝁</m:t>
+                              </m:r>
+                            </m:e>
+                            <m:sub>
+                              <m:r>
+                                <m:rPr>
+                                  <m:sty m:val="p"/>
+                                </m:rPr>
+                                <a:rPr lang="en-US" sz="2000" b="1" i="1" smtClean="0">
+                                  <a:solidFill>
+                                    <a:srgbClr val="F6BD5F"/>
+                                  </a:solidFill>
+                                  <a:latin typeface="Cambria Math" panose="02040503050406030204" pitchFamily="18" charset="0"/>
+                                </a:rPr>
+                                <m:t>E</m:t>
+                              </m:r>
+                            </m:sub>
+                          </m:sSub>
+                        </m:oMath>
+                      </m:oMathPara>
+                    </a14:m>
+                    <a:endParaRPr lang="en-US" sz="2000" b="1" dirty="0">
+                      <a:solidFill>
+                        <a:srgbClr val="F6BD5F"/>
+                      </a:solidFill>
+                    </a:endParaRPr>
+                  </a:p>
+                  <a:p>
+                    <a:endParaRPr lang="en-US" sz="2000" b="1" dirty="0">
+                      <a:solidFill>
+                        <a:srgbClr val="F6BD5F"/>
+                      </a:solidFill>
+                    </a:endParaRPr>
+                  </a:p>
+                </p:txBody>
+              </p:sp>
+            </mc:Choice>
+            <mc:Fallback>
+              <p:sp>
+                <p:nvSpPr>
+                  <p:cNvPr id="41" name="TextBox 40">
+                    <a:extLst>
+                      <a:ext uri="{FF2B5EF4-FFF2-40B4-BE49-F238E27FC236}">
+                        <a16:creationId xmlns:a16="http://schemas.microsoft.com/office/drawing/2014/main" id="{93DFD1D4-1004-FECC-F7F5-719B3280A53F}"/>
+                      </a:ext>
+                    </a:extLst>
+                  </p:cNvPr>
+                  <p:cNvSpPr txBox="1">
+                    <a:spLocks noRot="1" noChangeAspect="1" noMove="1" noResize="1" noEditPoints="1" noAdjustHandles="1" noChangeArrowheads="1" noChangeShapeType="1" noTextEdit="1"/>
+                  </p:cNvSpPr>
+                  <p:nvPr/>
+                </p:nvSpPr>
+                <p:spPr>
+                  <a:xfrm>
+                    <a:off x="6761073" y="6651727"/>
+                    <a:ext cx="340950" cy="615553"/>
+                  </a:xfrm>
+                  <a:prstGeom prst="rect">
+                    <a:avLst/>
+                  </a:prstGeom>
+                  <a:blipFill>
+                    <a:blip r:embed="rId8"/>
+                    <a:stretch>
+                      <a:fillRect l="-17857" r="-7143"/>
+                    </a:stretch>
+                  </a:blipFill>
+                </p:spPr>
+                <p:txBody>
+                  <a:bodyPr/>
+                  <a:lstStyle/>
+                  <a:p>
+                    <a:r>
+                      <a:rPr lang="en-US">
+                        <a:noFill/>
+                      </a:rPr>
+                      <a:t> </a:t>
+                    </a:r>
+                  </a:p>
+                </p:txBody>
+              </p:sp>
+            </mc:Fallback>
+          </mc:AlternateContent>
+          <p:cxnSp>
+            <p:nvCxnSpPr>
+              <p:cNvPr id="43" name="Straight Arrow Connector 42">
+                <a:extLst>
+                  <a:ext uri="{FF2B5EF4-FFF2-40B4-BE49-F238E27FC236}">
+                    <a16:creationId xmlns:a16="http://schemas.microsoft.com/office/drawing/2014/main" id="{1D99A336-64C8-53BD-CCA0-C74BE5F39BBE}"/>
+                  </a:ext>
+                </a:extLst>
+              </p:cNvPr>
+              <p:cNvCxnSpPr>
+                <a:cxnSpLocks/>
+              </p:cNvCxnSpPr>
+              <p:nvPr/>
+            </p:nvCxnSpPr>
+            <p:spPr>
+              <a:xfrm>
+                <a:off x="4974061" y="6186486"/>
+                <a:ext cx="4022984" cy="0"/>
+              </a:xfrm>
+              <a:prstGeom prst="straightConnector1">
+                <a:avLst/>
+              </a:prstGeom>
+              <a:ln>
+                <a:solidFill>
+                  <a:srgbClr val="FFC000"/>
+                </a:solidFill>
+                <a:headEnd type="triangle"/>
+                <a:tailEnd type="triangle"/>
+              </a:ln>
+            </p:spPr>
+            <p:style>
+              <a:lnRef idx="2">
+                <a:schemeClr val="accent1"/>
+              </a:lnRef>
+              <a:fillRef idx="0">
+                <a:schemeClr val="accent1"/>
+              </a:fillRef>
+              <a:effectRef idx="1">
+                <a:schemeClr val="accent1"/>
+              </a:effectRef>
+              <a:fontRef idx="minor">
+                <a:schemeClr val="tx1"/>
+              </a:fontRef>
+            </p:style>
+          </p:cxnSp>
+          <p:cxnSp>
+            <p:nvCxnSpPr>
+              <p:cNvPr id="45" name="Straight Arrow Connector 44">
+                <a:extLst>
+                  <a:ext uri="{FF2B5EF4-FFF2-40B4-BE49-F238E27FC236}">
+                    <a16:creationId xmlns:a16="http://schemas.microsoft.com/office/drawing/2014/main" id="{8C49943E-88F0-C0CC-56FC-C7A1F3A9A291}"/>
+                  </a:ext>
+                </a:extLst>
+              </p:cNvPr>
+              <p:cNvCxnSpPr>
+                <a:cxnSpLocks/>
+              </p:cNvCxnSpPr>
+              <p:nvPr/>
+            </p:nvCxnSpPr>
+            <p:spPr>
+              <a:xfrm>
+                <a:off x="4359018" y="6306229"/>
+                <a:ext cx="2380634" cy="0"/>
+              </a:xfrm>
+              <a:prstGeom prst="straightConnector1">
+                <a:avLst/>
+              </a:prstGeom>
+              <a:ln>
+                <a:solidFill>
+                  <a:srgbClr val="467C9D"/>
+                </a:solidFill>
+                <a:headEnd type="triangle"/>
+                <a:tailEnd type="triangle"/>
+              </a:ln>
+            </p:spPr>
+            <p:style>
+              <a:lnRef idx="2">
+                <a:schemeClr val="accent1"/>
+              </a:lnRef>
+              <a:fillRef idx="0">
+                <a:schemeClr val="accent1"/>
+              </a:fillRef>
+              <a:effectRef idx="1">
+                <a:schemeClr val="accent1"/>
+              </a:effectRef>
+              <a:fontRef idx="minor">
+                <a:schemeClr val="tx1"/>
+              </a:fontRef>
+            </p:style>
+          </p:cxnSp>
+          <p:cxnSp>
+            <p:nvCxnSpPr>
+              <p:cNvPr id="47" name="Straight Arrow Connector 46">
+                <a:extLst>
+                  <a:ext uri="{FF2B5EF4-FFF2-40B4-BE49-F238E27FC236}">
+                    <a16:creationId xmlns:a16="http://schemas.microsoft.com/office/drawing/2014/main" id="{F5D99511-7E2C-5FFA-B45B-E957585C5458}"/>
+                  </a:ext>
+                </a:extLst>
+              </p:cNvPr>
+              <p:cNvCxnSpPr>
+                <a:cxnSpLocks/>
+              </p:cNvCxnSpPr>
+              <p:nvPr/>
+            </p:nvCxnSpPr>
+            <p:spPr>
+              <a:xfrm>
+                <a:off x="4411067" y="6004895"/>
+                <a:ext cx="1602108" cy="0"/>
+              </a:xfrm>
+              <a:prstGeom prst="straightConnector1">
+                <a:avLst/>
+              </a:prstGeom>
+              <a:ln>
+                <a:solidFill>
+                  <a:srgbClr val="E1795D"/>
+                </a:solidFill>
+                <a:headEnd type="triangle"/>
+                <a:tailEnd type="triangle"/>
+              </a:ln>
+            </p:spPr>
+            <p:style>
+              <a:lnRef idx="2">
+                <a:schemeClr val="accent1"/>
+              </a:lnRef>
+              <a:fillRef idx="0">
+                <a:schemeClr val="accent1"/>
+              </a:fillRef>
+              <a:effectRef idx="1">
+                <a:schemeClr val="accent1"/>
+              </a:effectRef>
+              <a:fontRef idx="minor">
+                <a:schemeClr val="tx1"/>
+              </a:fontRef>
+            </p:style>
+          </p:cxnSp>
+          <p:cxnSp>
+            <p:nvCxnSpPr>
+              <p:cNvPr id="49" name="Straight Arrow Connector 48">
+                <a:extLst>
+                  <a:ext uri="{FF2B5EF4-FFF2-40B4-BE49-F238E27FC236}">
+                    <a16:creationId xmlns:a16="http://schemas.microsoft.com/office/drawing/2014/main" id="{031071CB-8A83-7B70-6AC2-44026C1EC2A6}"/>
+                  </a:ext>
+                </a:extLst>
+              </p:cNvPr>
+              <p:cNvCxnSpPr>
+                <a:cxnSpLocks/>
+              </p:cNvCxnSpPr>
+              <p:nvPr/>
+            </p:nvCxnSpPr>
+            <p:spPr>
+              <a:xfrm>
+                <a:off x="3014062" y="6429438"/>
+                <a:ext cx="3725590" cy="0"/>
+              </a:xfrm>
+              <a:prstGeom prst="straightConnector1">
+                <a:avLst/>
+              </a:prstGeom>
+              <a:ln>
+                <a:solidFill>
+                  <a:srgbClr val="5B835A"/>
+                </a:solidFill>
+                <a:headEnd type="triangle"/>
+                <a:tailEnd type="triangle"/>
+              </a:ln>
+            </p:spPr>
+            <p:style>
+              <a:lnRef idx="2">
+                <a:schemeClr val="accent1"/>
+              </a:lnRef>
+              <a:fillRef idx="0">
+                <a:schemeClr val="accent1"/>
+              </a:fillRef>
+              <a:effectRef idx="1">
+                <a:schemeClr val="accent1"/>
+              </a:effectRef>
+              <a:fontRef idx="minor">
+                <a:schemeClr val="tx1"/>
+              </a:fontRef>
+            </p:style>
+          </p:cxnSp>
+          <p:cxnSp>
+            <p:nvCxnSpPr>
+              <p:cNvPr id="51" name="Straight Arrow Connector 50">
+                <a:extLst>
+                  <a:ext uri="{FF2B5EF4-FFF2-40B4-BE49-F238E27FC236}">
+                    <a16:creationId xmlns:a16="http://schemas.microsoft.com/office/drawing/2014/main" id="{5FC5DE2A-1AA4-5AE1-6B86-F62422708AD8}"/>
+                  </a:ext>
+                </a:extLst>
+              </p:cNvPr>
+              <p:cNvCxnSpPr>
+                <a:cxnSpLocks/>
+              </p:cNvCxnSpPr>
+              <p:nvPr/>
+            </p:nvCxnSpPr>
+            <p:spPr>
+              <a:xfrm>
+                <a:off x="2923378" y="6119193"/>
+                <a:ext cx="2033270" cy="0"/>
+              </a:xfrm>
+              <a:prstGeom prst="straightConnector1">
+                <a:avLst/>
+              </a:prstGeom>
+              <a:ln>
+                <a:solidFill>
+                  <a:srgbClr val="825E65"/>
+                </a:solidFill>
+                <a:headEnd type="triangle"/>
+                <a:tailEnd type="triangle"/>
+              </a:ln>
+            </p:spPr>
+            <p:style>
+              <a:lnRef idx="2">
+                <a:schemeClr val="accent1"/>
+              </a:lnRef>
+              <a:fillRef idx="0">
+                <a:schemeClr val="accent1"/>
+              </a:fillRef>
+              <a:effectRef idx="1">
+                <a:schemeClr val="accent1"/>
+              </a:effectRef>
+              <a:fontRef idx="minor">
+                <a:schemeClr val="tx1"/>
+              </a:fontRef>
+            </p:style>
+          </p:cxnSp>
+          <p:cxnSp>
+            <p:nvCxnSpPr>
+              <p:cNvPr id="58" name="Straight Arrow Connector 57">
+                <a:extLst>
+                  <a:ext uri="{FF2B5EF4-FFF2-40B4-BE49-F238E27FC236}">
+                    <a16:creationId xmlns:a16="http://schemas.microsoft.com/office/drawing/2014/main" id="{1D47C2BE-97C7-5AAD-C7D9-0CAF8BFB3FB2}"/>
+                  </a:ext>
+                </a:extLst>
+              </p:cNvPr>
+              <p:cNvCxnSpPr>
+                <a:cxnSpLocks/>
+              </p:cNvCxnSpPr>
+              <p:nvPr/>
+            </p:nvCxnSpPr>
+            <p:spPr>
+              <a:xfrm>
+                <a:off x="1325480" y="2988064"/>
+                <a:ext cx="8805217" cy="0"/>
+              </a:xfrm>
+              <a:prstGeom prst="straightConnector1">
+                <a:avLst/>
+              </a:prstGeom>
+              <a:ln>
+                <a:solidFill>
+                  <a:schemeClr val="bg2">
+                    <a:lumMod val="50000"/>
+                  </a:schemeClr>
+                </a:solidFill>
+                <a:headEnd type="triangle"/>
+                <a:tailEnd type="triangle"/>
+              </a:ln>
+            </p:spPr>
+            <p:style>
+              <a:lnRef idx="2">
+                <a:schemeClr val="accent1"/>
+              </a:lnRef>
+              <a:fillRef idx="0">
+                <a:schemeClr val="accent1"/>
+              </a:fillRef>
+              <a:effectRef idx="1">
+                <a:schemeClr val="accent1"/>
+              </a:effectRef>
+              <a:fontRef idx="minor">
+                <a:schemeClr val="tx1"/>
+              </a:fontRef>
+            </p:style>
+          </p:cxnSp>
+          <mc:AlternateContent xmlns:mc="http://schemas.openxmlformats.org/markup-compatibility/2006">
+            <mc:Choice xmlns:a14="http://schemas.microsoft.com/office/drawing/2010/main" Requires="a14">
+              <p:sp>
+                <p:nvSpPr>
+                  <p:cNvPr id="60" name="TextBox 59">
+                    <a:extLst>
+                      <a:ext uri="{FF2B5EF4-FFF2-40B4-BE49-F238E27FC236}">
+                        <a16:creationId xmlns:a16="http://schemas.microsoft.com/office/drawing/2014/main" id="{99F515A5-D328-C211-CA4A-CD84C5785392}"/>
+                      </a:ext>
+                    </a:extLst>
+                  </p:cNvPr>
+                  <p:cNvSpPr txBox="1"/>
+                  <p:nvPr/>
+                </p:nvSpPr>
+                <p:spPr>
+                  <a:xfrm>
+                    <a:off x="1205947" y="3081536"/>
+                    <a:ext cx="759009" cy="314766"/>
+                  </a:xfrm>
+                  <a:prstGeom prst="rect">
+                    <a:avLst/>
+                  </a:prstGeom>
+                  <a:noFill/>
+                </p:spPr>
+                <p:txBody>
+                  <a:bodyPr wrap="square" lIns="0" tIns="0" rIns="0" bIns="0" rtlCol="0">
+                    <a:spAutoFit/>
+                  </a:bodyPr>
+                  <a:lstStyle/>
+                  <a:p>
+                    <a14:m>
+                      <m:oMathPara xmlns:m="http://schemas.openxmlformats.org/officeDocument/2006/math">
+                        <m:oMathParaPr>
+                          <m:jc m:val="centerGroup"/>
+                        </m:oMathParaPr>
+                        <m:oMath xmlns:m="http://schemas.openxmlformats.org/officeDocument/2006/math">
+                          <m:sSubSup>
+                            <m:sSubSupPr>
+                              <m:ctrlPr>
+                                <a:rPr lang="en-US" sz="2000" b="1" i="1" smtClean="0">
+                                  <a:solidFill>
+                                    <a:schemeClr val="tx1">
+                                      <a:lumMod val="65000"/>
+                                      <a:lumOff val="35000"/>
+                                    </a:schemeClr>
+                                  </a:solidFill>
+                                  <a:latin typeface="Cambria Math" panose="02040503050406030204" pitchFamily="18" charset="0"/>
+                                </a:rPr>
+                              </m:ctrlPr>
+                            </m:sSubSupPr>
+                            <m:e>
+                              <m:r>
+                                <a:rPr lang="en-US" sz="2000" b="1" i="1" smtClean="0">
+                                  <a:solidFill>
+                                    <a:schemeClr val="tx1">
+                                      <a:lumMod val="65000"/>
+                                      <a:lumOff val="35000"/>
+                                    </a:schemeClr>
+                                  </a:solidFill>
+                                  <a:latin typeface="Cambria Math" panose="02040503050406030204" pitchFamily="18" charset="0"/>
+                                </a:rPr>
+                                <m:t>𝝈</m:t>
+                              </m:r>
+                            </m:e>
+                            <m:sub>
+                              <m:r>
+                                <a:rPr lang="en-US" sz="2000" b="1" i="1" smtClean="0">
+                                  <a:solidFill>
+                                    <a:schemeClr val="tx1">
+                                      <a:lumMod val="65000"/>
+                                      <a:lumOff val="35000"/>
+                                    </a:schemeClr>
+                                  </a:solidFill>
+                                  <a:latin typeface="Cambria Math" panose="02040503050406030204" pitchFamily="18" charset="0"/>
+                                </a:rPr>
+                                <m:t>𝜶</m:t>
+                              </m:r>
+                            </m:sub>
+                            <m:sup>
+                              <m:r>
+                                <a:rPr lang="en-US" sz="2000" b="1" i="1" smtClean="0">
+                                  <a:solidFill>
+                                    <a:schemeClr val="tx1">
+                                      <a:lumMod val="65000"/>
+                                      <a:lumOff val="35000"/>
+                                    </a:schemeClr>
+                                  </a:solidFill>
+                                  <a:latin typeface="Cambria Math" panose="02040503050406030204" pitchFamily="18" charset="0"/>
+                                </a:rPr>
+                                <m:t>𝟐</m:t>
+                              </m:r>
+                            </m:sup>
+                          </m:sSubSup>
+                        </m:oMath>
+                      </m:oMathPara>
+                    </a14:m>
+                    <a:endParaRPr lang="en-US" sz="2000" b="1" dirty="0">
+                      <a:solidFill>
+                        <a:schemeClr val="tx1">
+                          <a:lumMod val="65000"/>
+                          <a:lumOff val="35000"/>
+                        </a:schemeClr>
+                      </a:solidFill>
+                    </a:endParaRPr>
+                  </a:p>
+                </p:txBody>
+              </p:sp>
+            </mc:Choice>
+            <mc:Fallback>
+              <p:sp>
+                <p:nvSpPr>
+                  <p:cNvPr id="60" name="TextBox 59">
+                    <a:extLst>
+                      <a:ext uri="{FF2B5EF4-FFF2-40B4-BE49-F238E27FC236}">
+                        <a16:creationId xmlns:a16="http://schemas.microsoft.com/office/drawing/2014/main" id="{99F515A5-D328-C211-CA4A-CD84C5785392}"/>
+                      </a:ext>
+                    </a:extLst>
+                  </p:cNvPr>
+                  <p:cNvSpPr txBox="1">
+                    <a:spLocks noRot="1" noChangeAspect="1" noMove="1" noResize="1" noEditPoints="1" noAdjustHandles="1" noChangeArrowheads="1" noChangeShapeType="1" noTextEdit="1"/>
+                  </p:cNvSpPr>
+                  <p:nvPr/>
+                </p:nvSpPr>
+                <p:spPr>
+                  <a:xfrm>
+                    <a:off x="1205947" y="3081536"/>
+                    <a:ext cx="759009" cy="314766"/>
+                  </a:xfrm>
+                  <a:prstGeom prst="rect">
+                    <a:avLst/>
+                  </a:prstGeom>
+                  <a:blipFill>
+                    <a:blip r:embed="rId9"/>
+                    <a:stretch>
+                      <a:fillRect t="-3846" b="-7692"/>
+                    </a:stretch>
+                  </a:blipFill>
+                </p:spPr>
+                <p:txBody>
+                  <a:bodyPr/>
+                  <a:lstStyle/>
+                  <a:p>
+                    <a:r>
+                      <a:rPr lang="en-US">
+                        <a:noFill/>
+                      </a:rPr>
+                      <a:t> </a:t>
+                    </a:r>
+                  </a:p>
+                </p:txBody>
+              </p:sp>
+            </mc:Fallback>
+          </mc:AlternateContent>
+          <mc:AlternateContent xmlns:mc="http://schemas.openxmlformats.org/markup-compatibility/2006">
+            <mc:Choice xmlns:a14="http://schemas.microsoft.com/office/drawing/2010/main" Requires="a14">
+              <p:sp>
+                <p:nvSpPr>
+                  <p:cNvPr id="61" name="TextBox 60">
+                    <a:extLst>
+                      <a:ext uri="{FF2B5EF4-FFF2-40B4-BE49-F238E27FC236}">
+                        <a16:creationId xmlns:a16="http://schemas.microsoft.com/office/drawing/2014/main" id="{0C73520D-7D4F-DAAB-6555-771081ED2139}"/>
+                      </a:ext>
+                    </a:extLst>
+                  </p:cNvPr>
+                  <p:cNvSpPr txBox="1"/>
+                  <p:nvPr/>
+                </p:nvSpPr>
+                <p:spPr>
+                  <a:xfrm>
+                    <a:off x="9194267" y="6102324"/>
+                    <a:ext cx="759009" cy="314766"/>
+                  </a:xfrm>
+                  <a:prstGeom prst="rect">
+                    <a:avLst/>
+                  </a:prstGeom>
+                  <a:noFill/>
+                </p:spPr>
+                <p:txBody>
+                  <a:bodyPr wrap="square" lIns="0" tIns="0" rIns="0" bIns="0" rtlCol="0">
+                    <a:spAutoFit/>
+                  </a:bodyPr>
+                  <a:lstStyle/>
+                  <a:p>
+                    <a14:m>
+                      <m:oMathPara xmlns:m="http://schemas.openxmlformats.org/officeDocument/2006/math">
+                        <m:oMathParaPr>
+                          <m:jc m:val="centerGroup"/>
+                        </m:oMathParaPr>
+                        <m:oMath xmlns:m="http://schemas.openxmlformats.org/officeDocument/2006/math">
+                          <m:r>
+                            <m:rPr>
+                              <m:sty m:val="p"/>
+                            </m:rPr>
+                            <a:rPr lang="en-US" sz="2000" b="1" i="1" smtClean="0">
+                              <a:solidFill>
+                                <a:schemeClr val="tx1">
+                                  <a:lumMod val="85000"/>
+                                  <a:lumOff val="15000"/>
+                                </a:schemeClr>
+                              </a:solidFill>
+                              <a:latin typeface="Cambria Math" panose="02040503050406030204" pitchFamily="18" charset="0"/>
+                            </a:rPr>
+                            <m:t>σ</m:t>
+                          </m:r>
+                        </m:oMath>
+                      </m:oMathPara>
+                    </a14:m>
+                    <a:endParaRPr lang="en-US" sz="2000" b="1" dirty="0">
+                      <a:solidFill>
+                        <a:schemeClr val="tx1">
+                          <a:lumMod val="85000"/>
+                          <a:lumOff val="15000"/>
+                        </a:schemeClr>
+                      </a:solidFill>
+                    </a:endParaRPr>
+                  </a:p>
+                </p:txBody>
+              </p:sp>
+            </mc:Choice>
+            <mc:Fallback>
+              <p:sp>
+                <p:nvSpPr>
+                  <p:cNvPr id="61" name="TextBox 60">
+                    <a:extLst>
+                      <a:ext uri="{FF2B5EF4-FFF2-40B4-BE49-F238E27FC236}">
+                        <a16:creationId xmlns:a16="http://schemas.microsoft.com/office/drawing/2014/main" id="{0C73520D-7D4F-DAAB-6555-771081ED2139}"/>
+                      </a:ext>
+                    </a:extLst>
+                  </p:cNvPr>
+                  <p:cNvSpPr txBox="1">
+                    <a:spLocks noRot="1" noChangeAspect="1" noMove="1" noResize="1" noEditPoints="1" noAdjustHandles="1" noChangeArrowheads="1" noChangeShapeType="1" noTextEdit="1"/>
+                  </p:cNvSpPr>
+                  <p:nvPr/>
+                </p:nvSpPr>
+                <p:spPr>
+                  <a:xfrm>
+                    <a:off x="9194267" y="6102324"/>
+                    <a:ext cx="759009" cy="314766"/>
+                  </a:xfrm>
+                  <a:prstGeom prst="rect">
+                    <a:avLst/>
+                  </a:prstGeom>
+                  <a:blipFill>
+                    <a:blip r:embed="rId10"/>
+                    <a:stretch>
+                      <a:fillRect/>
+                    </a:stretch>
+                  </a:blipFill>
+                </p:spPr>
+                <p:txBody>
+                  <a:bodyPr/>
+                  <a:lstStyle/>
+                  <a:p>
+                    <a:r>
+                      <a:rPr lang="en-US">
+                        <a:noFill/>
+                      </a:rPr>
+                      <a:t> </a:t>
+                    </a:r>
+                  </a:p>
+                </p:txBody>
+              </p:sp>
+            </mc:Fallback>
+          </mc:AlternateContent>
+          <p:sp>
+            <p:nvSpPr>
+              <p:cNvPr id="66" name="TextBox 65">
+                <a:extLst>
+                  <a:ext uri="{FF2B5EF4-FFF2-40B4-BE49-F238E27FC236}">
+                    <a16:creationId xmlns:a16="http://schemas.microsoft.com/office/drawing/2014/main" id="{04EC279C-6677-03B4-D1E4-717126AE8E01}"/>
+                  </a:ext>
+                </a:extLst>
+              </p:cNvPr>
+              <p:cNvSpPr txBox="1"/>
+              <p:nvPr/>
+            </p:nvSpPr>
+            <p:spPr>
+              <a:xfrm>
+                <a:off x="7968347" y="7086602"/>
+                <a:ext cx="184731" cy="369332"/>
+              </a:xfrm>
+              <a:prstGeom prst="rect">
+                <a:avLst/>
+              </a:prstGeom>
+              <a:noFill/>
+            </p:spPr>
+            <p:txBody>
+              <a:bodyPr wrap="none" rtlCol="0">
+                <a:spAutoFit/>
+              </a:bodyPr>
+              <a:lstStyle/>
+              <a:p>
+                <a:endParaRPr lang="en-US" dirty="0"/>
+              </a:p>
+            </p:txBody>
+          </p:sp>
+          <p:sp>
+            <p:nvSpPr>
+              <p:cNvPr id="67" name="Right Brace 66">
+                <a:extLst>
+                  <a:ext uri="{FF2B5EF4-FFF2-40B4-BE49-F238E27FC236}">
+                    <a16:creationId xmlns:a16="http://schemas.microsoft.com/office/drawing/2014/main" id="{F683B5FE-1DD6-90A8-B325-6F09DDC0B3E1}"/>
+                  </a:ext>
+                </a:extLst>
+              </p:cNvPr>
+              <p:cNvSpPr/>
+              <p:nvPr/>
+            </p:nvSpPr>
+            <p:spPr>
+              <a:xfrm>
+                <a:off x="9194267" y="6004895"/>
+                <a:ext cx="96691" cy="463909"/>
+              </a:xfrm>
+              <a:prstGeom prst="rightBrace">
+                <a:avLst/>
+              </a:prstGeom>
+            </p:spPr>
+            <p:style>
+              <a:lnRef idx="2">
+                <a:schemeClr val="dk1"/>
+              </a:lnRef>
+              <a:fillRef idx="0">
+                <a:schemeClr val="dk1"/>
+              </a:fillRef>
+              <a:effectRef idx="1">
+                <a:schemeClr val="dk1"/>
+              </a:effectRef>
+              <a:fontRef idx="minor">
+                <a:schemeClr val="tx1"/>
+              </a:fontRef>
+            </p:style>
+            <p:txBody>
+              <a:bodyPr rtlCol="0" anchor="ctr"/>
+              <a:lstStyle/>
+              <a:p>
+                <a:pPr algn="ctr"/>
+                <a:endParaRPr lang="en-US"/>
+              </a:p>
+            </p:txBody>
+          </p:sp>
+          <p:sp>
+            <p:nvSpPr>
+              <p:cNvPr id="68" name="TextBox 67">
+                <a:extLst>
+                  <a:ext uri="{FF2B5EF4-FFF2-40B4-BE49-F238E27FC236}">
+                    <a16:creationId xmlns:a16="http://schemas.microsoft.com/office/drawing/2014/main" id="{59B3F19F-8B25-2052-6750-2B94348D6985}"/>
+                  </a:ext>
+                </a:extLst>
+              </p:cNvPr>
+              <p:cNvSpPr txBox="1"/>
+              <p:nvPr/>
+            </p:nvSpPr>
+            <p:spPr>
+              <a:xfrm>
+                <a:off x="9440408" y="5442460"/>
+                <a:ext cx="1677662" cy="369332"/>
+              </a:xfrm>
+              <a:prstGeom prst="rect">
+                <a:avLst/>
+              </a:prstGeom>
+              <a:noFill/>
+            </p:spPr>
+            <p:txBody>
+              <a:bodyPr wrap="square" rtlCol="0">
+                <a:spAutoFit/>
+              </a:bodyPr>
+              <a:lstStyle/>
+              <a:p>
+                <a:pPr algn="ctr"/>
+                <a:r>
+                  <a:rPr lang="en-US" b="1" dirty="0" err="1">
+                    <a:latin typeface="Aptos Light" panose="020B0004020202020204" pitchFamily="34" charset="0"/>
+                  </a:rPr>
+                  <a:t>Nível</a:t>
+                </a:r>
+                <a:r>
+                  <a:rPr lang="en-US" b="1" dirty="0">
+                    <a:latin typeface="Aptos Light" panose="020B0004020202020204" pitchFamily="34" charset="0"/>
+                  </a:rPr>
+                  <a:t> de </a:t>
+                </a:r>
+                <a:r>
+                  <a:rPr lang="en-US" b="1" dirty="0" err="1">
+                    <a:latin typeface="Aptos Light" panose="020B0004020202020204" pitchFamily="34" charset="0"/>
+                  </a:rPr>
+                  <a:t>grupo</a:t>
+                </a:r>
+                <a:endParaRPr lang="en-US" b="1" dirty="0">
+                  <a:latin typeface="Aptos Light" panose="020B0004020202020204" pitchFamily="34" charset="0"/>
+                </a:endParaRPr>
+              </a:p>
+            </p:txBody>
+          </p:sp>
+        </p:grpSp>
+      </p:grpSp>
+    </p:spTree>
+    <p:extLst>
+      <p:ext uri="{BB962C8B-B14F-4D97-AF65-F5344CB8AC3E}">
+        <p14:creationId xmlns:p14="http://schemas.microsoft.com/office/powerpoint/2010/main" val="1995668596"/>
+      </p:ext>
+    </p:extLst>
+  </p:cSld>
+  <p:clrMapOvr>
+    <a:masterClrMapping/>
+  </p:clrMapOvr>
+</p:sld>
+</file>
+
+<file path=ppt/slides/slide14.xml><?xml version="1.0" encoding="utf-8"?>
+<p:sld xmlns:a="http://schemas.openxmlformats.org/drawingml/2006/main" xmlns:r="http://schemas.openxmlformats.org/officeDocument/2006/relationships" xmlns:p="http://schemas.openxmlformats.org/presentationml/2006/main">
+  <p:cSld>
+    <p:spTree>
+      <p:nvGrpSpPr>
+        <p:cNvPr id="1" name=""/>
+        <p:cNvGrpSpPr/>
+        <p:nvPr/>
+      </p:nvGrpSpPr>
+      <p:grpSpPr>
+        <a:xfrm>
+          <a:off x="0" y="0"/>
+          <a:ext cx="0" cy="0"/>
+          <a:chOff x="0" y="0"/>
+          <a:chExt cx="0" cy="0"/>
+        </a:xfrm>
+      </p:grpSpPr>
+      <p:grpSp>
+        <p:nvGrpSpPr>
           <p:cNvPr id="69" name="Group 68">
             <a:extLst>
               <a:ext uri="{FF2B5EF4-FFF2-40B4-BE49-F238E27FC236}">
@@ -14461,7 +16851,7 @@
 </p:sld>
 </file>
 
-<file path=ppt/slides/slide14.xml><?xml version="1.0" encoding="utf-8"?>
+<file path=ppt/slides/slide15.xml><?xml version="1.0" encoding="utf-8"?>
 <p:sld xmlns:a="http://schemas.openxmlformats.org/drawingml/2006/main" xmlns:r="http://schemas.openxmlformats.org/officeDocument/2006/relationships" xmlns:p="http://schemas.openxmlformats.org/presentationml/2006/main">
   <p:cSld>
     <p:spTree>
@@ -20777,7 +23167,7 @@
 </p:sld>
 </file>
 
-<file path=ppt/slides/slide15.xml><?xml version="1.0" encoding="utf-8"?>
+<file path=ppt/slides/slide16.xml><?xml version="1.0" encoding="utf-8"?>
 <p:sld xmlns:a="http://schemas.openxmlformats.org/drawingml/2006/main" xmlns:r="http://schemas.openxmlformats.org/officeDocument/2006/relationships" xmlns:p="http://schemas.openxmlformats.org/presentationml/2006/main">
   <p:cSld>
     <p:spTree>
@@ -23627,7 +26017,7 @@
 </p:sld>
 </file>
 
-<file path=ppt/slides/slide16.xml><?xml version="1.0" encoding="utf-8"?>
+<file path=ppt/slides/slide17.xml><?xml version="1.0" encoding="utf-8"?>
 <p:sld xmlns:a="http://schemas.openxmlformats.org/drawingml/2006/main" xmlns:r="http://schemas.openxmlformats.org/officeDocument/2006/relationships" xmlns:p="http://schemas.openxmlformats.org/presentationml/2006/main">
   <p:cSld>
     <p:spTree>
@@ -25943,7 +28333,7 @@
 </p:sld>
 </file>
 
-<file path=ppt/slides/slide17.xml><?xml version="1.0" encoding="utf-8"?>
+<file path=ppt/slides/slide18.xml><?xml version="1.0" encoding="utf-8"?>
 <p:sld xmlns:a="http://schemas.openxmlformats.org/drawingml/2006/main" xmlns:r="http://schemas.openxmlformats.org/officeDocument/2006/relationships" xmlns:p="http://schemas.openxmlformats.org/presentationml/2006/main">
   <p:cSld>
     <p:spTree>
@@ -28776,7 +31166,7 @@
 </p:sld>
 </file>
 
-<file path=ppt/slides/slide18.xml><?xml version="1.0" encoding="utf-8"?>
+<file path=ppt/slides/slide19.xml><?xml version="1.0" encoding="utf-8"?>
 <p:sld xmlns:a="http://schemas.openxmlformats.org/drawingml/2006/main" xmlns:r="http://schemas.openxmlformats.org/officeDocument/2006/relationships" xmlns:p="http://schemas.openxmlformats.org/presentationml/2006/main">
   <p:cSld>
     <p:spTree>

</xml_diff>

<commit_message>
Working on lecture 5: glmms and gamms
</commit_message>
<xml_diff>
--- a/Figuras/Figuras_prep.pptx
+++ b/Figuras/Figuras_prep.pptx
@@ -144,7 +144,7 @@
   <pc:docChgLst>
     <pc:chgData name="Marie-Christine Rufener" userId="2d6664cfb518d05c" providerId="LiveId" clId="{946B3BF8-DE9F-57F9-A118-BDE1986E26EE}"/>
     <pc:docChg chg="undo redo custSel addSld delSld modSld sldOrd">
-      <pc:chgData name="Marie-Christine Rufener" userId="2d6664cfb518d05c" providerId="LiveId" clId="{946B3BF8-DE9F-57F9-A118-BDE1986E26EE}" dt="2026-08-17T10:21:21.622" v="9022" actId="207"/>
+      <pc:chgData name="Marie-Christine Rufener" userId="2d6664cfb518d05c" providerId="LiveId" clId="{946B3BF8-DE9F-57F9-A118-BDE1986E26EE}" dt="2026-08-17T22:14:54.401" v="9128" actId="164"/>
       <pc:docMkLst>
         <pc:docMk/>
       </pc:docMkLst>
@@ -3891,14 +3891,14 @@
           </ac:cxnSpMkLst>
         </pc:cxnChg>
       </pc:sldChg>
-      <pc:sldChg chg="addSp modSp new mod">
-        <pc:chgData name="Marie-Christine Rufener" userId="2d6664cfb518d05c" providerId="LiveId" clId="{946B3BF8-DE9F-57F9-A118-BDE1986E26EE}" dt="2026-08-17T10:21:21.622" v="9022" actId="207"/>
+      <pc:sldChg chg="addSp delSp modSp new mod">
+        <pc:chgData name="Marie-Christine Rufener" userId="2d6664cfb518d05c" providerId="LiveId" clId="{946B3BF8-DE9F-57F9-A118-BDE1986E26EE}" dt="2026-08-17T22:14:54.401" v="9128" actId="164"/>
         <pc:sldMkLst>
           <pc:docMk/>
           <pc:sldMk cId="1317523250" sldId="281"/>
         </pc:sldMkLst>
-        <pc:spChg chg="mod">
-          <ac:chgData name="Marie-Christine Rufener" userId="2d6664cfb518d05c" providerId="LiveId" clId="{946B3BF8-DE9F-57F9-A118-BDE1986E26EE}" dt="2026-08-17T10:19:57.029" v="9010" actId="208"/>
+        <pc:spChg chg="mod topLvl">
+          <ac:chgData name="Marie-Christine Rufener" userId="2d6664cfb518d05c" providerId="LiveId" clId="{946B3BF8-DE9F-57F9-A118-BDE1986E26EE}" dt="2026-08-17T22:13:38.026" v="9025" actId="165"/>
           <ac:spMkLst>
             <pc:docMk/>
             <pc:sldMk cId="1317523250" sldId="281"/>
@@ -3906,7 +3906,7 @@
           </ac:spMkLst>
         </pc:spChg>
         <pc:spChg chg="mod">
-          <ac:chgData name="Marie-Christine Rufener" userId="2d6664cfb518d05c" providerId="LiveId" clId="{946B3BF8-DE9F-57F9-A118-BDE1986E26EE}" dt="2026-08-17T10:20:08.596" v="9011" actId="208"/>
+          <ac:chgData name="Marie-Christine Rufener" userId="2d6664cfb518d05c" providerId="LiveId" clId="{946B3BF8-DE9F-57F9-A118-BDE1986E26EE}" dt="2026-08-17T22:13:59.178" v="9059" actId="1037"/>
           <ac:spMkLst>
             <pc:docMk/>
             <pc:sldMk cId="1317523250" sldId="281"/>
@@ -3914,7 +3914,7 @@
           </ac:spMkLst>
         </pc:spChg>
         <pc:spChg chg="mod">
-          <ac:chgData name="Marie-Christine Rufener" userId="2d6664cfb518d05c" providerId="LiveId" clId="{946B3BF8-DE9F-57F9-A118-BDE1986E26EE}" dt="2026-08-17T10:20:48.308" v="9017" actId="207"/>
+          <ac:chgData name="Marie-Christine Rufener" userId="2d6664cfb518d05c" providerId="LiveId" clId="{946B3BF8-DE9F-57F9-A118-BDE1986E26EE}" dt="2026-08-17T22:14:45.787" v="9127" actId="1035"/>
           <ac:spMkLst>
             <pc:docMk/>
             <pc:sldMk cId="1317523250" sldId="281"/>
@@ -3922,7 +3922,7 @@
           </ac:spMkLst>
         </pc:spChg>
         <pc:spChg chg="mod">
-          <ac:chgData name="Marie-Christine Rufener" userId="2d6664cfb518d05c" providerId="LiveId" clId="{946B3BF8-DE9F-57F9-A118-BDE1986E26EE}" dt="2026-08-17T10:21:21.622" v="9022" actId="207"/>
+          <ac:chgData name="Marie-Christine Rufener" userId="2d6664cfb518d05c" providerId="LiveId" clId="{946B3BF8-DE9F-57F9-A118-BDE1986E26EE}" dt="2026-08-17T22:13:59.178" v="9059" actId="1037"/>
           <ac:spMkLst>
             <pc:docMk/>
             <pc:sldMk cId="1317523250" sldId="281"/>
@@ -3930,23 +3930,23 @@
           </ac:spMkLst>
         </pc:spChg>
         <pc:spChg chg="mod">
-          <ac:chgData name="Marie-Christine Rufener" userId="2d6664cfb518d05c" providerId="LiveId" clId="{946B3BF8-DE9F-57F9-A118-BDE1986E26EE}" dt="2026-08-17T10:21:21.622" v="9022" actId="207"/>
+          <ac:chgData name="Marie-Christine Rufener" userId="2d6664cfb518d05c" providerId="LiveId" clId="{946B3BF8-DE9F-57F9-A118-BDE1986E26EE}" dt="2026-08-17T22:13:59.178" v="9059" actId="1037"/>
           <ac:spMkLst>
             <pc:docMk/>
             <pc:sldMk cId="1317523250" sldId="281"/>
             <ac:spMk id="7" creationId="{B6D32CF6-5EFA-BFE8-6B76-C0E5F196C8C8}"/>
           </ac:spMkLst>
         </pc:spChg>
-        <pc:spChg chg="mod">
-          <ac:chgData name="Marie-Christine Rufener" userId="2d6664cfb518d05c" providerId="LiveId" clId="{946B3BF8-DE9F-57F9-A118-BDE1986E26EE}" dt="2026-08-17T10:21:21.622" v="9022" actId="207"/>
+        <pc:spChg chg="mod topLvl">
+          <ac:chgData name="Marie-Christine Rufener" userId="2d6664cfb518d05c" providerId="LiveId" clId="{946B3BF8-DE9F-57F9-A118-BDE1986E26EE}" dt="2026-08-17T22:13:59.178" v="9059" actId="1037"/>
           <ac:spMkLst>
             <pc:docMk/>
             <pc:sldMk cId="1317523250" sldId="281"/>
             <ac:spMk id="8" creationId="{DC2A6A2F-5FE8-CCCE-16EC-55315E8BDB99}"/>
           </ac:spMkLst>
         </pc:spChg>
-        <pc:spChg chg="mod">
-          <ac:chgData name="Marie-Christine Rufener" userId="2d6664cfb518d05c" providerId="LiveId" clId="{946B3BF8-DE9F-57F9-A118-BDE1986E26EE}" dt="2026-08-17T10:20:39.948" v="9016" actId="207"/>
+        <pc:spChg chg="mod topLvl">
+          <ac:chgData name="Marie-Christine Rufener" userId="2d6664cfb518d05c" providerId="LiveId" clId="{946B3BF8-DE9F-57F9-A118-BDE1986E26EE}" dt="2026-08-17T22:13:59.178" v="9059" actId="1037"/>
           <ac:spMkLst>
             <pc:docMk/>
             <pc:sldMk cId="1317523250" sldId="281"/>
@@ -3954,15 +3954,15 @@
           </ac:spMkLst>
         </pc:spChg>
         <pc:spChg chg="mod">
-          <ac:chgData name="Marie-Christine Rufener" userId="2d6664cfb518d05c" providerId="LiveId" clId="{946B3BF8-DE9F-57F9-A118-BDE1986E26EE}" dt="2026-08-17T10:20:52.353" v="9018" actId="207"/>
+          <ac:chgData name="Marie-Christine Rufener" userId="2d6664cfb518d05c" providerId="LiveId" clId="{946B3BF8-DE9F-57F9-A118-BDE1986E26EE}" dt="2026-08-17T22:14:45.787" v="9127" actId="1035"/>
           <ac:spMkLst>
             <pc:docMk/>
             <pc:sldMk cId="1317523250" sldId="281"/>
             <ac:spMk id="10" creationId="{F67DCFCD-DB56-82ED-EAF1-E8064FF91158}"/>
           </ac:spMkLst>
         </pc:spChg>
-        <pc:spChg chg="mod">
-          <ac:chgData name="Marie-Christine Rufener" userId="2d6664cfb518d05c" providerId="LiveId" clId="{946B3BF8-DE9F-57F9-A118-BDE1986E26EE}" dt="2026-08-17T10:20:56.134" v="9019" actId="207"/>
+        <pc:spChg chg="mod topLvl">
+          <ac:chgData name="Marie-Christine Rufener" userId="2d6664cfb518d05c" providerId="LiveId" clId="{946B3BF8-DE9F-57F9-A118-BDE1986E26EE}" dt="2026-08-17T22:14:45.787" v="9127" actId="1035"/>
           <ac:spMkLst>
             <pc:docMk/>
             <pc:sldMk cId="1317523250" sldId="281"/>
@@ -3970,7 +3970,7 @@
           </ac:spMkLst>
         </pc:spChg>
         <pc:spChg chg="mod">
-          <ac:chgData name="Marie-Christine Rufener" userId="2d6664cfb518d05c" providerId="LiveId" clId="{946B3BF8-DE9F-57F9-A118-BDE1986E26EE}" dt="2026-08-17T10:20:39.948" v="9016" actId="207"/>
+          <ac:chgData name="Marie-Christine Rufener" userId="2d6664cfb518d05c" providerId="LiveId" clId="{946B3BF8-DE9F-57F9-A118-BDE1986E26EE}" dt="2026-08-17T22:13:59.178" v="9059" actId="1037"/>
           <ac:spMkLst>
             <pc:docMk/>
             <pc:sldMk cId="1317523250" sldId="281"/>
@@ -3978,7 +3978,7 @@
           </ac:spMkLst>
         </pc:spChg>
         <pc:spChg chg="mod">
-          <ac:chgData name="Marie-Christine Rufener" userId="2d6664cfb518d05c" providerId="LiveId" clId="{946B3BF8-DE9F-57F9-A118-BDE1986E26EE}" dt="2026-08-17T10:20:39.948" v="9016" actId="207"/>
+          <ac:chgData name="Marie-Christine Rufener" userId="2d6664cfb518d05c" providerId="LiveId" clId="{946B3BF8-DE9F-57F9-A118-BDE1986E26EE}" dt="2026-08-17T22:13:59.178" v="9059" actId="1037"/>
           <ac:spMkLst>
             <pc:docMk/>
             <pc:sldMk cId="1317523250" sldId="281"/>
@@ -3993,16 +3993,16 @@
             <ac:spMk id="16" creationId="{17DD91F4-C93E-1F19-7D6D-76168928FDBB}"/>
           </ac:spMkLst>
         </pc:spChg>
-        <pc:spChg chg="mod">
-          <ac:chgData name="Marie-Christine Rufener" userId="2d6664cfb518d05c" providerId="LiveId" clId="{946B3BF8-DE9F-57F9-A118-BDE1986E26EE}" dt="2026-08-17T10:21:21.622" v="9022" actId="207"/>
+        <pc:spChg chg="mod topLvl">
+          <ac:chgData name="Marie-Christine Rufener" userId="2d6664cfb518d05c" providerId="LiveId" clId="{946B3BF8-DE9F-57F9-A118-BDE1986E26EE}" dt="2026-08-17T22:13:38.026" v="9025" actId="165"/>
           <ac:spMkLst>
             <pc:docMk/>
             <pc:sldMk cId="1317523250" sldId="281"/>
             <ac:spMk id="17" creationId="{9ABC8DE1-6494-1DE1-DC2B-DA8750B45B17}"/>
           </ac:spMkLst>
         </pc:spChg>
-        <pc:spChg chg="mod">
-          <ac:chgData name="Marie-Christine Rufener" userId="2d6664cfb518d05c" providerId="LiveId" clId="{946B3BF8-DE9F-57F9-A118-BDE1986E26EE}" dt="2026-08-17T10:21:21.622" v="9022" actId="207"/>
+        <pc:spChg chg="mod topLvl">
+          <ac:chgData name="Marie-Christine Rufener" userId="2d6664cfb518d05c" providerId="LiveId" clId="{946B3BF8-DE9F-57F9-A118-BDE1986E26EE}" dt="2026-08-17T22:13:38.026" v="9025" actId="165"/>
           <ac:spMkLst>
             <pc:docMk/>
             <pc:sldMk cId="1317523250" sldId="281"/>
@@ -4017,8 +4017,8 @@
             <ac:spMk id="19" creationId="{75EDB5F0-0E1B-D224-717C-82A056C8CEAF}"/>
           </ac:spMkLst>
         </pc:spChg>
-        <pc:spChg chg="mod">
-          <ac:chgData name="Marie-Christine Rufener" userId="2d6664cfb518d05c" providerId="LiveId" clId="{946B3BF8-DE9F-57F9-A118-BDE1986E26EE}" dt="2026-08-17T10:20:39.948" v="9016" actId="207"/>
+        <pc:spChg chg="mod topLvl">
+          <ac:chgData name="Marie-Christine Rufener" userId="2d6664cfb518d05c" providerId="LiveId" clId="{946B3BF8-DE9F-57F9-A118-BDE1986E26EE}" dt="2026-08-17T22:13:38.026" v="9025" actId="165"/>
           <ac:spMkLst>
             <pc:docMk/>
             <pc:sldMk cId="1317523250" sldId="281"/>
@@ -4033,8 +4033,8 @@
             <ac:spMk id="21" creationId="{D3D39D18-F239-752D-F61F-7069BE45694C}"/>
           </ac:spMkLst>
         </pc:spChg>
-        <pc:spChg chg="mod">
-          <ac:chgData name="Marie-Christine Rufener" userId="2d6664cfb518d05c" providerId="LiveId" clId="{946B3BF8-DE9F-57F9-A118-BDE1986E26EE}" dt="2026-08-17T10:19:50.234" v="9009" actId="208"/>
+        <pc:spChg chg="mod topLvl">
+          <ac:chgData name="Marie-Christine Rufener" userId="2d6664cfb518d05c" providerId="LiveId" clId="{946B3BF8-DE9F-57F9-A118-BDE1986E26EE}" dt="2026-08-17T22:14:33.332" v="9105" actId="1038"/>
           <ac:spMkLst>
             <pc:docMk/>
             <pc:sldMk cId="1317523250" sldId="281"/>
@@ -4042,7 +4042,7 @@
           </ac:spMkLst>
         </pc:spChg>
         <pc:spChg chg="mod">
-          <ac:chgData name="Marie-Christine Rufener" userId="2d6664cfb518d05c" providerId="LiveId" clId="{946B3BF8-DE9F-57F9-A118-BDE1986E26EE}" dt="2026-08-17T10:21:21.622" v="9022" actId="207"/>
+          <ac:chgData name="Marie-Christine Rufener" userId="2d6664cfb518d05c" providerId="LiveId" clId="{946B3BF8-DE9F-57F9-A118-BDE1986E26EE}" dt="2026-08-17T22:14:33.332" v="9105" actId="1038"/>
           <ac:spMkLst>
             <pc:docMk/>
             <pc:sldMk cId="1317523250" sldId="281"/>
@@ -4050,7 +4050,7 @@
           </ac:spMkLst>
         </pc:spChg>
         <pc:spChg chg="mod">
-          <ac:chgData name="Marie-Christine Rufener" userId="2d6664cfb518d05c" providerId="LiveId" clId="{946B3BF8-DE9F-57F9-A118-BDE1986E26EE}" dt="2026-08-17T10:21:21.622" v="9022" actId="207"/>
+          <ac:chgData name="Marie-Christine Rufener" userId="2d6664cfb518d05c" providerId="LiveId" clId="{946B3BF8-DE9F-57F9-A118-BDE1986E26EE}" dt="2026-08-17T22:14:33.332" v="9105" actId="1038"/>
           <ac:spMkLst>
             <pc:docMk/>
             <pc:sldMk cId="1317523250" sldId="281"/>
@@ -4058,15 +4058,15 @@
           </ac:spMkLst>
         </pc:spChg>
         <pc:spChg chg="mod">
-          <ac:chgData name="Marie-Christine Rufener" userId="2d6664cfb518d05c" providerId="LiveId" clId="{946B3BF8-DE9F-57F9-A118-BDE1986E26EE}" dt="2026-08-17T10:21:21.622" v="9022" actId="207"/>
+          <ac:chgData name="Marie-Christine Rufener" userId="2d6664cfb518d05c" providerId="LiveId" clId="{946B3BF8-DE9F-57F9-A118-BDE1986E26EE}" dt="2026-08-17T22:14:33.332" v="9105" actId="1038"/>
           <ac:spMkLst>
             <pc:docMk/>
             <pc:sldMk cId="1317523250" sldId="281"/>
             <ac:spMk id="25" creationId="{4302A502-26FE-1226-6EBA-1AFC84F796ED}"/>
           </ac:spMkLst>
         </pc:spChg>
-        <pc:spChg chg="mod">
-          <ac:chgData name="Marie-Christine Rufener" userId="2d6664cfb518d05c" providerId="LiveId" clId="{946B3BF8-DE9F-57F9-A118-BDE1986E26EE}" dt="2026-08-17T10:20:39.948" v="9016" actId="207"/>
+        <pc:spChg chg="mod topLvl">
+          <ac:chgData name="Marie-Christine Rufener" userId="2d6664cfb518d05c" providerId="LiveId" clId="{946B3BF8-DE9F-57F9-A118-BDE1986E26EE}" dt="2026-08-17T22:14:33.332" v="9105" actId="1038"/>
           <ac:spMkLst>
             <pc:docMk/>
             <pc:sldMk cId="1317523250" sldId="281"/>
@@ -4074,31 +4074,47 @@
           </ac:spMkLst>
         </pc:spChg>
         <pc:spChg chg="mod">
-          <ac:chgData name="Marie-Christine Rufener" userId="2d6664cfb518d05c" providerId="LiveId" clId="{946B3BF8-DE9F-57F9-A118-BDE1986E26EE}" dt="2026-08-17T10:20:39.948" v="9016" actId="207"/>
+          <ac:chgData name="Marie-Christine Rufener" userId="2d6664cfb518d05c" providerId="LiveId" clId="{946B3BF8-DE9F-57F9-A118-BDE1986E26EE}" dt="2026-08-17T22:14:33.332" v="9105" actId="1038"/>
           <ac:spMkLst>
             <pc:docMk/>
             <pc:sldMk cId="1317523250" sldId="281"/>
             <ac:spMk id="27" creationId="{068A16A8-520E-8568-5144-6DC0A35EFD77}"/>
           </ac:spMkLst>
         </pc:spChg>
-        <pc:spChg chg="mod">
-          <ac:chgData name="Marie-Christine Rufener" userId="2d6664cfb518d05c" providerId="LiveId" clId="{946B3BF8-DE9F-57F9-A118-BDE1986E26EE}" dt="2026-08-17T10:20:39.948" v="9016" actId="207"/>
+        <pc:spChg chg="mod topLvl">
+          <ac:chgData name="Marie-Christine Rufener" userId="2d6664cfb518d05c" providerId="LiveId" clId="{946B3BF8-DE9F-57F9-A118-BDE1986E26EE}" dt="2026-08-17T22:14:33.332" v="9105" actId="1038"/>
           <ac:spMkLst>
             <pc:docMk/>
             <pc:sldMk cId="1317523250" sldId="281"/>
             <ac:spMk id="28" creationId="{A363D7A0-E6D6-5E3F-6FB1-106D74F7F6A7}"/>
           </ac:spMkLst>
         </pc:spChg>
+        <pc:spChg chg="add del mod">
+          <ac:chgData name="Marie-Christine Rufener" userId="2d6664cfb518d05c" providerId="LiveId" clId="{946B3BF8-DE9F-57F9-A118-BDE1986E26EE}" dt="2026-08-17T22:14:39.941" v="9119" actId="478"/>
+          <ac:spMkLst>
+            <pc:docMk/>
+            <pc:sldMk cId="1317523250" sldId="281"/>
+            <ac:spMk id="29" creationId="{80CE45B7-9935-6ABB-A762-EC37C1E2BCC5}"/>
+          </ac:spMkLst>
+        </pc:spChg>
         <pc:grpChg chg="mod">
-          <ac:chgData name="Marie-Christine Rufener" userId="2d6664cfb518d05c" providerId="LiveId" clId="{946B3BF8-DE9F-57F9-A118-BDE1986E26EE}" dt="2026-08-17T10:19:09.132" v="9003" actId="1076"/>
+          <ac:chgData name="Marie-Christine Rufener" userId="2d6664cfb518d05c" providerId="LiveId" clId="{946B3BF8-DE9F-57F9-A118-BDE1986E26EE}" dt="2026-08-17T10:21:38.757" v="9024" actId="1076"/>
           <ac:grpSpMkLst>
             <pc:docMk/>
             <pc:sldMk cId="1317523250" sldId="281"/>
             <ac:grpSpMk id="2" creationId="{77938A7D-FB3C-C450-051A-093FA01F5955}"/>
           </ac:grpSpMkLst>
         </pc:grpChg>
+        <pc:grpChg chg="add">
+          <ac:chgData name="Marie-Christine Rufener" userId="2d6664cfb518d05c" providerId="LiveId" clId="{946B3BF8-DE9F-57F9-A118-BDE1986E26EE}" dt="2026-08-17T22:14:54.401" v="9128" actId="164"/>
+          <ac:grpSpMkLst>
+            <pc:docMk/>
+            <pc:sldMk cId="1317523250" sldId="281"/>
+            <ac:grpSpMk id="30" creationId="{95F4C916-1E30-0A15-DB5F-8B5B6D741FF0}"/>
+          </ac:grpSpMkLst>
+        </pc:grpChg>
         <pc:cxnChg chg="mod">
-          <ac:chgData name="Marie-Christine Rufener" userId="2d6664cfb518d05c" providerId="LiveId" clId="{946B3BF8-DE9F-57F9-A118-BDE1986E26EE}" dt="2026-08-17T10:20:20.343" v="9013" actId="692"/>
+          <ac:chgData name="Marie-Christine Rufener" userId="2d6664cfb518d05c" providerId="LiveId" clId="{946B3BF8-DE9F-57F9-A118-BDE1986E26EE}" dt="2026-08-17T22:14:03.042" v="9068" actId="1037"/>
           <ac:cxnSpMkLst>
             <pc:docMk/>
             <pc:sldMk cId="1317523250" sldId="281"/>
@@ -4106,7 +4122,7 @@
           </ac:cxnSpMkLst>
         </pc:cxnChg>
         <pc:cxnChg chg="mod">
-          <ac:chgData name="Marie-Christine Rufener" userId="2d6664cfb518d05c" providerId="LiveId" clId="{946B3BF8-DE9F-57F9-A118-BDE1986E26EE}" dt="2026-08-17T10:20:20.343" v="9013" actId="692"/>
+          <ac:chgData name="Marie-Christine Rufener" userId="2d6664cfb518d05c" providerId="LiveId" clId="{946B3BF8-DE9F-57F9-A118-BDE1986E26EE}" dt="2026-08-17T22:14:38.396" v="9118" actId="1037"/>
           <ac:cxnSpMkLst>
             <pc:docMk/>
             <pc:sldMk cId="1317523250" sldId="281"/>
@@ -33850,10 +33866,10 @@
       </p:grpSpPr>
       <p:grpSp>
         <p:nvGrpSpPr>
-          <p:cNvPr id="2" name="Group 1">
+          <p:cNvPr id="30" name="Group 29">
             <a:extLst>
               <a:ext uri="{FF2B5EF4-FFF2-40B4-BE49-F238E27FC236}">
-                <a16:creationId xmlns:a16="http://schemas.microsoft.com/office/drawing/2014/main" id="{77938A7D-FB3C-C450-051A-093FA01F5955}"/>
+                <a16:creationId xmlns:a16="http://schemas.microsoft.com/office/drawing/2014/main" id="{95F4C916-1E30-0A15-DB5F-8B5B6D741FF0}"/>
               </a:ext>
             </a:extLst>
           </p:cNvPr>
@@ -33862,10 +33878,10 @@
         </p:nvGrpSpPr>
         <p:grpSpPr>
           <a:xfrm>
-            <a:off x="84666" y="1232221"/>
-            <a:ext cx="11798305" cy="4549527"/>
-            <a:chOff x="84666" y="1232221"/>
-            <a:chExt cx="11798305" cy="4549527"/>
+            <a:off x="-803618" y="1023213"/>
+            <a:ext cx="13496488" cy="4758535"/>
+            <a:chOff x="-803618" y="1023213"/>
+            <a:chExt cx="13496488" cy="4758535"/>
           </a:xfrm>
         </p:grpSpPr>
         <p:sp>
@@ -34290,7 +34306,7 @@
           </p:nvSpPr>
           <p:spPr>
             <a:xfrm>
-              <a:off x="106262" y="1846678"/>
+              <a:off x="-782022" y="1846678"/>
               <a:ext cx="3441272" cy="3927589"/>
             </a:xfrm>
             <a:custGeom>
@@ -34698,7 +34714,7 @@
           </p:nvSpPr>
           <p:spPr>
             <a:xfrm>
-              <a:off x="84666" y="1232221"/>
+              <a:off x="-803618" y="1023213"/>
               <a:ext cx="3420536" cy="430887"/>
             </a:xfrm>
             <a:prstGeom prst="rect">
@@ -34741,7 +34757,7 @@
               </p:nvSpPr>
               <p:spPr>
                 <a:xfrm>
-                  <a:off x="525247" y="2619519"/>
+                  <a:off x="-363037" y="2619519"/>
                   <a:ext cx="2480102" cy="338554"/>
                 </a:xfrm>
                 <a:prstGeom prst="rect">
@@ -34962,7 +34978,7 @@
               </p:nvSpPr>
               <p:spPr>
                 <a:xfrm>
-                  <a:off x="525247" y="2619519"/>
+                  <a:off x="-363037" y="2619519"/>
                   <a:ext cx="2480102" cy="338554"/>
                 </a:xfrm>
                 <a:prstGeom prst="rect">
@@ -35006,7 +35022,7 @@
               </p:nvSpPr>
               <p:spPr>
                 <a:xfrm>
-                  <a:off x="805032" y="3976818"/>
+                  <a:off x="-83252" y="3976818"/>
                   <a:ext cx="1861022" cy="338554"/>
                 </a:xfrm>
                 <a:prstGeom prst="rect">
@@ -35240,7 +35256,7 @@
               </p:nvSpPr>
               <p:spPr>
                 <a:xfrm>
-                  <a:off x="805032" y="3976818"/>
+                  <a:off x="-83252" y="3976818"/>
                   <a:ext cx="1861022" cy="338554"/>
                 </a:xfrm>
                 <a:prstGeom prst="rect">
@@ -35249,7 +35265,7 @@
                 <a:blipFill>
                   <a:blip r:embed="rId3"/>
                   <a:stretch>
-                    <a:fillRect l="-3401" t="-7143" r="-1361" b="-35714"/>
+                    <a:fillRect l="-3378" t="-7143" r="-676" b="-35714"/>
                   </a:stretch>
                 </a:blipFill>
               </p:spPr>
@@ -35284,7 +35300,7 @@
               </p:nvSpPr>
               <p:spPr>
                 <a:xfrm>
-                  <a:off x="1208440" y="5179108"/>
+                  <a:off x="320156" y="5179108"/>
                   <a:ext cx="950004" cy="371640"/>
                 </a:xfrm>
                 <a:prstGeom prst="rect">
@@ -35467,7 +35483,7 @@
               </p:nvSpPr>
               <p:spPr>
                 <a:xfrm>
-                  <a:off x="1208440" y="5179108"/>
+                  <a:off x="320156" y="5179108"/>
                   <a:ext cx="950004" cy="371640"/>
                 </a:xfrm>
                 <a:prstGeom prst="rect">
@@ -35476,7 +35492,7 @@
                 <a:blipFill>
                   <a:blip r:embed="rId4"/>
                   <a:stretch>
-                    <a:fillRect l="-8000" t="-6667" r="-4000" b="-36667"/>
+                    <a:fillRect l="-6667" t="-6667" r="-4000" b="-36667"/>
                   </a:stretch>
                 </a:blipFill>
               </p:spPr>
@@ -35509,7 +35525,7 @@
           </p:nvSpPr>
           <p:spPr>
             <a:xfrm>
-              <a:off x="338506" y="2117613"/>
+              <a:off x="-549778" y="2117613"/>
               <a:ext cx="2777067" cy="400110"/>
             </a:xfrm>
             <a:prstGeom prst="rect">
@@ -35582,7 +35598,7 @@
           </p:nvSpPr>
           <p:spPr>
             <a:xfrm>
-              <a:off x="4224865" y="1232221"/>
+              <a:off x="4224865" y="1023213"/>
               <a:ext cx="3420536" cy="430887"/>
             </a:xfrm>
             <a:prstGeom prst="rect">
@@ -35623,7 +35639,7 @@
           </p:nvSpPr>
           <p:spPr>
             <a:xfrm>
-              <a:off x="8322732" y="1232221"/>
+              <a:off x="9132631" y="1023213"/>
               <a:ext cx="3462868" cy="430887"/>
             </a:xfrm>
             <a:prstGeom prst="rect">
@@ -35664,7 +35680,7 @@
           </p:nvSpPr>
           <p:spPr>
             <a:xfrm>
-              <a:off x="376765" y="3497104"/>
+              <a:off x="-511519" y="3497104"/>
               <a:ext cx="2777067" cy="400110"/>
             </a:xfrm>
             <a:prstGeom prst="rect">
@@ -35737,7 +35753,7 @@
           </p:nvSpPr>
           <p:spPr>
             <a:xfrm>
-              <a:off x="299114" y="4754264"/>
+              <a:off x="-589170" y="4754264"/>
               <a:ext cx="2777067" cy="400110"/>
             </a:xfrm>
             <a:prstGeom prst="rect">
@@ -35812,7 +35828,7 @@
           </p:nvCxnSpPr>
           <p:spPr>
             <a:xfrm>
-              <a:off x="3843866" y="1846680"/>
+              <a:off x="3425855" y="1846680"/>
               <a:ext cx="0" cy="3927588"/>
             </a:xfrm>
             <a:prstGeom prst="line">
@@ -35857,7 +35873,7 @@
           </p:nvCxnSpPr>
           <p:spPr>
             <a:xfrm>
-              <a:off x="8026399" y="1846680"/>
+              <a:off x="8444411" y="1846680"/>
               <a:ext cx="0" cy="3927588"/>
             </a:xfrm>
             <a:prstGeom prst="line">
@@ -36863,7 +36879,7 @@
           </p:nvSpPr>
           <p:spPr>
             <a:xfrm>
-              <a:off x="8441699" y="1854159"/>
+              <a:off x="9251598" y="1854159"/>
               <a:ext cx="3441272" cy="3927589"/>
             </a:xfrm>
             <a:custGeom>
@@ -37273,7 +37289,7 @@
               </p:nvSpPr>
               <p:spPr>
                 <a:xfrm>
-                  <a:off x="8977352" y="2614952"/>
+                  <a:off x="9787251" y="2614952"/>
                   <a:ext cx="2560381" cy="338554"/>
                 </a:xfrm>
                 <a:prstGeom prst="rect">
@@ -37465,7 +37481,7 @@
               </p:nvSpPr>
               <p:spPr>
                 <a:xfrm>
-                  <a:off x="8977352" y="2614952"/>
+                  <a:off x="9787251" y="2614952"/>
                   <a:ext cx="2560381" cy="338554"/>
                 </a:xfrm>
                 <a:prstGeom prst="rect">
@@ -37474,7 +37490,7 @@
                 <a:blipFill>
                   <a:blip r:embed="rId8"/>
                   <a:stretch>
-                    <a:fillRect l="-2475" t="-7143" b="-32143"/>
+                    <a:fillRect l="-1970" t="-7143" b="-32143"/>
                   </a:stretch>
                 </a:blipFill>
               </p:spPr>
@@ -37509,7 +37525,7 @@
               </p:nvSpPr>
               <p:spPr>
                 <a:xfrm>
-                  <a:off x="9182959" y="3905977"/>
+                  <a:off x="9992858" y="3905977"/>
                   <a:ext cx="1861022" cy="338554"/>
                 </a:xfrm>
                 <a:prstGeom prst="rect">
@@ -37743,7 +37759,7 @@
               </p:nvSpPr>
               <p:spPr>
                 <a:xfrm>
-                  <a:off x="9182959" y="3905977"/>
+                  <a:off x="9992858" y="3905977"/>
                   <a:ext cx="1861022" cy="338554"/>
                 </a:xfrm>
                 <a:prstGeom prst="rect">
@@ -37752,7 +37768,7 @@
                 <a:blipFill>
                   <a:blip r:embed="rId9"/>
                   <a:stretch>
-                    <a:fillRect l="-2703" t="-10714" r="-1351" b="-32143"/>
+                    <a:fillRect l="-3378" t="-10714" r="-1351" b="-32143"/>
                   </a:stretch>
                 </a:blipFill>
               </p:spPr>
@@ -37787,7 +37803,7 @@
               </p:nvSpPr>
               <p:spPr>
                 <a:xfrm>
-                  <a:off x="9250534" y="5155916"/>
+                  <a:off x="10060433" y="5155916"/>
                   <a:ext cx="1795235" cy="371640"/>
                 </a:xfrm>
                 <a:prstGeom prst="rect">
@@ -37995,7 +38011,7 @@
               </p:nvSpPr>
               <p:spPr>
                 <a:xfrm>
-                  <a:off x="9250534" y="5155916"/>
+                  <a:off x="10060433" y="5155916"/>
                   <a:ext cx="1795235" cy="371640"/>
                 </a:xfrm>
                 <a:prstGeom prst="rect">
@@ -38037,7 +38053,7 @@
           </p:nvSpPr>
           <p:spPr>
             <a:xfrm>
-              <a:off x="8716433" y="2046772"/>
+              <a:off x="9526332" y="2046772"/>
               <a:ext cx="2777067" cy="400110"/>
             </a:xfrm>
             <a:prstGeom prst="rect">
@@ -38110,7 +38126,7 @@
           </p:nvSpPr>
           <p:spPr>
             <a:xfrm>
-              <a:off x="8754692" y="3426263"/>
+              <a:off x="9564591" y="3426263"/>
               <a:ext cx="2777067" cy="400110"/>
             </a:xfrm>
             <a:prstGeom prst="rect">
@@ -38183,7 +38199,7 @@
           </p:nvSpPr>
           <p:spPr>
             <a:xfrm>
-              <a:off x="8677041" y="4683423"/>
+              <a:off x="9486940" y="4683423"/>
               <a:ext cx="2777067" cy="400110"/>
             </a:xfrm>
             <a:prstGeom prst="rect">

</xml_diff>